<commit_message>
Expand alternative energy presentation: more text and three new slides
Co-Authored-By: Claude Sonnet 5.5 <noreply@anthropic.com>
Claude-Session: https://claude.ai/code/session_0119SPq8eRKyTVqhrTEFqUAc
</commit_message>
<xml_diff>
--- a/out/Безопасность_альтернативной_энергетики.pptx
+++ b/out/Безопасность_альтернативной_энергетики.pptx
@@ -14,10 +14,13 @@
     <p:sldId id="279" r:id="rId30"/>
     <p:sldId id="280" r:id="rId31"/>
     <p:sldId id="288" r:id="rId39"/>
+    <p:sldId id="287" r:id="rId38"/>
     <p:sldId id="281" r:id="rId32"/>
     <p:sldId id="282" r:id="rId33"/>
+    <p:sldId id="291" r:id="rId42"/>
     <p:sldId id="283" r:id="rId34"/>
     <p:sldId id="284" r:id="rId35"/>
+    <p:sldId id="292" r:id="rId43"/>
     <p:sldId id="285" r:id="rId36"/>
     <p:sldId id="289" r:id="rId40"/>
     <p:sldId id="290" r:id="rId41"/>
@@ -883,7 +886,7 @@
           <a:lstStyle/>
           <a:p>
             <a:r>
-              <a:t>Электротравмы самые тяжёлые. Риски: дуговой разряд на постоянном токе, обратное питание из сети или от панелей, остаточный заряд конденсаторов инверторов, влага и повреждённая изоляция. Меры: наряд-допуск, отключение и блокировка с замком и биркой на каждом разъединителе, проверка отсутствия напряжения прибором и правильные СИЗ: диэлектрический инструмент и перчатки. Золотое правило: считать всё находящимся под напряжением, пока вы сами не убедились в обратном.</a:t>
+              <a:t>Накопители энергии. Литиевые аккумуляторы опасны тепловым разгоном: перегрев, перезаряд или повреждение запускают цепную реакцию, ячейки загораются одна за другой, а батарея может вспыхнуть повторно уже после тушения. При горении выделяются едкие и горючие газы, в том числе фтороводород, поэтому без изолирующих средств защиты дыхания в помещение не входят. Отключённая батарея остаётся под напряжением, а короткое замыкание даёт огромные токи и дугу. Меры: контроль температуры и напряжения модулей, автоматическое пожаротушение, разделение секций, дистанция между контейнерами, план реагирования и обучение.</a:t>
             </a:r>
           </a:p>
         </p:txBody>
@@ -953,7 +956,7 @@
           <a:lstStyle/>
           <a:p>
             <a:r>
-              <a:t>Работа на высоте включает три задачи. Первая: предотвратить падение. Это ограждения, анкерные линии, привязь с двумя лонжами и осмотр СИЗ перед подъёмом. Вторая: подготовить спасение, потому что повисание в привязи опасно уже через несколько минут. Нужны набор для эвакуации, обученная группа и план спасения для каждого объекта. Третья: учесть погоду. При сильном ветре, грозе, льде и жаре подъём запрещают в пределах, указанных в инструкции. Допуск к высоте означает обучение, медосмотр, исправные СИЗ и страхующего напарника.</a:t>
+              <a:t>Электротравмы самые тяжёлые. Риски: дуговой разряд на постоянном токе, обратное питание из сети или от панелей, остаточный заряд конденсаторов инверторов, влага и повреждённая изоляция. Меры: наряд-допуск, отключение и блокировка с замком и биркой на каждом разъединителе, проверка отсутствия напряжения прибором и правильные СИЗ: диэлектрический инструмент и перчатки. Золотое правило: считать всё находящимся под напряжением, пока вы сами не убедились в обратном.</a:t>
             </a:r>
           </a:p>
         </p:txBody>
@@ -1023,7 +1026,7 @@
           <a:lstStyle/>
           <a:p>
             <a:r>
-              <a:t>В таблице СИЗ по частям тела. Голова: каска с подбородочным ремнём. Падение: страховочная привязь, лонжи и анкерные точки. Руки: диэлектрические перчатки, а для рам панелей ещё и перчатки от пореза. Ноги: диэлектрические боты или нескользящая обувь с жёстким носком. Лицо и тело: щиток или очки от дуги и огнестойкая одежда. Погода: головной убор, очки от солнца и запас воды. Внизу про знаки по ГОСТ Р 12.4.026: жёлтые предупреждают, синие предписывают, красные запрещают, зелёные показывают путь эвакуации.</a:t>
+              <a:t>Работа на высоте включает три задачи. Первая: предотвратить падение. Это ограждения, анкерные линии, привязь с двумя лонжами и осмотр СИЗ перед подъёмом. Вторая: подготовить спасение, потому что повисание в привязи опасно уже через несколько минут. Нужны набор для эвакуации, обученная группа и план спасения для каждого объекта. Третья: учесть погоду. При сильном ветре, грозе, льде и жаре подъём запрещают в пределах, указанных в инструкции. Допуск к высоте означает обучение, медосмотр, исправные СИЗ и страхующего напарника.</a:t>
             </a:r>
           </a:p>
         </p:txBody>
@@ -1093,7 +1096,7 @@
           <a:lstStyle/>
           <a:p>
             <a:r>
-              <a:t>Безопасная работа идёт по порядку. Первое: наряд-допуск, инструктаж, ответственный и страхующий. Второе: оценка условий: ветер, гроза, обледенение, жара, освещение. Третье: отключение и блокировка, на разъединители вешают замок и бирку. Четвёртое: проверка прибором, что напряжения нет. Помните, что панели днём остаются под напряжением. Пятое: выполнение работ вдвоём, со связью и страховкой. Шестое: закрытие наряда: собрать людей, снять блокировки и включать только по команде ответственного.</a:t>
+              <a:t>Допуск персонала. Для работы с электроустановками нужна группа по электробезопасности, от второй до пятой, она присваивается по результатам проверки знаний. Для работ на высоте нужны обучение, медосмотр и группа допуска: первая, вторая или третья. Инструктажи бывают вводный, первичный, повторный, внеплановый и целевой перед опасными работами. В ветроэнергетике применяют курсы GWO по высоте, спасению с башни, первой помощи и пожарной безопасности. Периодические медосмотры исключают работу при противопоказаниях.</a:t>
             </a:r>
           </a:p>
         </p:txBody>
@@ -1163,7 +1166,7 @@
           <a:lstStyle/>
           <a:p>
             <a:r>
-              <a:t>Плакат собирает главное. Слева состав солнечной станции и опасный узел на каждом этапе: панели с постоянным током до 1500 вольт, инвертор с зарядом конденсаторов, трансформатор с высоким напряжением и подстанция с обратным питанием. В центре четыре группы опасностей при работах: падение, электричество, огонь и погода. Справа знаки безопасности четырёх цветов: предупреждающие, предписывающие, запрещающие и эвакуационные. Внизу девиз: отключи, проверь, заблокируй, пристегнись.</a:t>
+              <a:t>В таблице СИЗ по частям тела. Голова: каска с подбородочным ремнём. Падение: страховочная привязь, лонжи и анкерные точки. Руки: диэлектрические перчатки, а для рам панелей ещё и перчатки от пореза. Ноги: диэлектрические боты или нескользящая обувь с жёстким носком. Лицо и тело: щиток или очки от дуги и огнестойкая одежда. Погода: головной убор, очки от солнца и запас воды. Внизу про знаки по ГОСТ Р 12.4.026: жёлтые предупреждают, синие предписывают, красные запрещают, зелёные показывают путь эвакуации.</a:t>
             </a:r>
           </a:p>
         </p:txBody>
@@ -1233,7 +1236,7 @@
           <a:lstStyle/>
           <a:p>
             <a:r>
-              <a:t>При аварии. Поражение током: обесточить цепь или отстранить человека предметом из диэлектрика, не прикасаться к пострадавшему под напряжением, при отсутствии дыхания начать реанимацию. При падении без необходимости не перемещать пострадавшего. Пожар: сообщить диспетчеру и позвонить в 112, электроустановку под напряжением водой не тушить, от литиевых батарей держаться дальше из-за дыма, эвакуироваться по указанному пути. Диспетчеру назвать объект, место и число пострадавших.</a:t>
+              <a:t>Безопасная работа идёт по порядку. Первое: наряд-допуск, инструктаж, ответственный и страхующий. Второе: оценка условий: ветер, гроза, обледенение, жара, освещение. Третье: отключение и блокировка, на разъединители вешают замок и бирку. Четвёртое: проверка прибором, что напряжения нет. Помните, что панели днём остаются под напряжением. Пятое: выполнение работ вдвоём, со связью и страховкой. Шестое: закрытие наряда: собрать людей, снять блокировки и включать только по команде ответственного.</a:t>
             </a:r>
           </a:p>
         </p:txBody>
@@ -1303,7 +1306,7 @@
           <a:lstStyle/>
           <a:p>
             <a:r>
-              <a:t>Итоги. Первое: главные риски на объектах ВИЭ: электричество, высота и огонь. Второе: постоянный ток на панелях опасен, пока на них падает свет. Третье: работы только по наряду, с блокировкой и проверкой отсутствия напряжения. Четвёртое: высота требует допуска, СИЗ и плана спасения. Пятое: нужно знать знаки безопасности и порядок действий при аварии. Чистая энергия безопасна, когда безопасна работа с ней. Спасибо за внимание!</a:t>
+              <a:t>Типичные ошибки. Первое: работа без отключения и проверки напряжения ведёт к поражению током и дуге. Второе: снятие чужой блокировки на минуту может подать напряжение на людей, поэтому блокировку снимает только тот, кто её установил. Третье: работа в одиночку, когда некому помочь. Четвёртое: отказ от страховки ненадолго, а падение происходит именно в этот момент. Пятое: спешка и усталость приводят к пропуску шагов, помогают планирование времени и чек-лист. Шестое: игнорирование погоды, поэтому смотрят прогноз и мерят ветер.</a:t>
             </a:r>
           </a:p>
         </p:txBody>
@@ -1329,6 +1332,216 @@
 </file>
 
 <file path=ppt/notesSlides/notesSlide26.xml><?xml version="1.0" encoding="utf-8"?>
+<p:notes xmlns:a="http://schemas.openxmlformats.org/drawingml/2006/main" xmlns:p="http://schemas.openxmlformats.org/presentationml/2006/main" xmlns:r="http://schemas.openxmlformats.org/officeDocument/2006/relationships">
+  <p:cSld>
+    <p:spTree>
+      <p:nvGrpSpPr>
+        <p:cNvPr id="1" name=""/>
+        <p:cNvGrpSpPr/>
+        <p:nvPr/>
+      </p:nvGrpSpPr>
+      <p:grpSpPr>
+        <a:xfrm>
+          <a:off x="0" y="0"/>
+          <a:ext cx="0" cy="0"/>
+          <a:chOff x="0" y="0"/>
+          <a:chExt cx="0" cy="0"/>
+        </a:xfrm>
+      </p:grpSpPr>
+      <p:sp>
+        <p:nvSpPr>
+          <p:cNvPr id="2" name="Slide Image Placeholder 1"/>
+          <p:cNvSpPr>
+            <a:spLocks noGrp="1"/>
+          </p:cNvSpPr>
+          <p:nvPr>
+            <p:ph type="sldImg" idx="2"/>
+          </p:nvPr>
+        </p:nvSpPr>
+        <p:spPr/>
+      </p:sp>
+      <p:sp>
+        <p:nvSpPr>
+          <p:cNvPr id="3" name="Notes Placeholder 2"/>
+          <p:cNvSpPr>
+            <a:spLocks noGrp="1"/>
+          </p:cNvSpPr>
+          <p:nvPr>
+            <p:ph type="body" idx="3" sz="quarter"/>
+          </p:nvPr>
+        </p:nvSpPr>
+        <p:spPr/>
+        <p:txBody>
+          <a:bodyPr/>
+          <a:lstStyle/>
+          <a:p>
+            <a:r>
+              <a:t>Плакат собирает главное. Слева состав солнечной станции и опасный узел на каждом этапе: панели с постоянным током до 1500 вольт, инвертор с зарядом конденсаторов, трансформатор с высоким напряжением и подстанция с обратным питанием. В центре четыре группы опасностей при работах: падение, электричество, огонь и погода. Справа знаки безопасности четырёх цветов: предупреждающие, предписывающие, запрещающие и эвакуационные. Внизу девиз: отключи, проверь, заблокируй, пристегнись.</a:t>
+            </a:r>
+          </a:p>
+        </p:txBody>
+      </p:sp>
+      <p:sp>
+        <p:nvSpPr>
+          <p:cNvPr id="4" name="Slide Number Placeholder 3"/>
+          <p:cNvSpPr>
+            <a:spLocks noGrp="1"/>
+          </p:cNvSpPr>
+          <p:nvPr>
+            <p:ph type="sldNum" idx="5" sz="quarter"/>
+          </p:nvPr>
+        </p:nvSpPr>
+        <p:spPr/>
+      </p:sp>
+    </p:spTree>
+  </p:cSld>
+  <p:clrMapOvr>
+    <a:masterClrMapping/>
+  </p:clrMapOvr>
+</p:notes>
+</file>
+
+<file path=ppt/notesSlides/notesSlide27.xml><?xml version="1.0" encoding="utf-8"?>
+<p:notes xmlns:a="http://schemas.openxmlformats.org/drawingml/2006/main" xmlns:p="http://schemas.openxmlformats.org/presentationml/2006/main" xmlns:r="http://schemas.openxmlformats.org/officeDocument/2006/relationships">
+  <p:cSld>
+    <p:spTree>
+      <p:nvGrpSpPr>
+        <p:cNvPr id="1" name=""/>
+        <p:cNvGrpSpPr/>
+        <p:nvPr/>
+      </p:nvGrpSpPr>
+      <p:grpSpPr>
+        <a:xfrm>
+          <a:off x="0" y="0"/>
+          <a:ext cx="0" cy="0"/>
+          <a:chOff x="0" y="0"/>
+          <a:chExt cx="0" cy="0"/>
+        </a:xfrm>
+      </p:grpSpPr>
+      <p:sp>
+        <p:nvSpPr>
+          <p:cNvPr id="2" name="Slide Image Placeholder 1"/>
+          <p:cNvSpPr>
+            <a:spLocks noGrp="1"/>
+          </p:cNvSpPr>
+          <p:nvPr>
+            <p:ph type="sldImg" idx="2"/>
+          </p:nvPr>
+        </p:nvSpPr>
+        <p:spPr/>
+      </p:sp>
+      <p:sp>
+        <p:nvSpPr>
+          <p:cNvPr id="3" name="Notes Placeholder 2"/>
+          <p:cNvSpPr>
+            <a:spLocks noGrp="1"/>
+          </p:cNvSpPr>
+          <p:nvPr>
+            <p:ph type="body" idx="3" sz="quarter"/>
+          </p:nvPr>
+        </p:nvSpPr>
+        <p:spPr/>
+        <p:txBody>
+          <a:bodyPr/>
+          <a:lstStyle/>
+          <a:p>
+            <a:r>
+              <a:t>При аварии. Поражение током: обесточить цепь или отстранить человека предметом из диэлектрика, не прикасаться к пострадавшему под напряжением, при отсутствии дыхания начать реанимацию. При падении без необходимости не перемещать пострадавшего. Пожар: сообщить диспетчеру и позвонить в 112, электроустановку под напряжением водой не тушить, от литиевых батарей держаться дальше из-за дыма, эвакуироваться по указанному пути. Диспетчеру назвать объект, место и число пострадавших.</a:t>
+            </a:r>
+          </a:p>
+        </p:txBody>
+      </p:sp>
+      <p:sp>
+        <p:nvSpPr>
+          <p:cNvPr id="4" name="Slide Number Placeholder 3"/>
+          <p:cNvSpPr>
+            <a:spLocks noGrp="1"/>
+          </p:cNvSpPr>
+          <p:nvPr>
+            <p:ph type="sldNum" idx="5" sz="quarter"/>
+          </p:nvPr>
+        </p:nvSpPr>
+        <p:spPr/>
+      </p:sp>
+    </p:spTree>
+  </p:cSld>
+  <p:clrMapOvr>
+    <a:masterClrMapping/>
+  </p:clrMapOvr>
+</p:notes>
+</file>
+
+<file path=ppt/notesSlides/notesSlide28.xml><?xml version="1.0" encoding="utf-8"?>
+<p:notes xmlns:a="http://schemas.openxmlformats.org/drawingml/2006/main" xmlns:p="http://schemas.openxmlformats.org/presentationml/2006/main" xmlns:r="http://schemas.openxmlformats.org/officeDocument/2006/relationships">
+  <p:cSld>
+    <p:spTree>
+      <p:nvGrpSpPr>
+        <p:cNvPr id="1" name=""/>
+        <p:cNvGrpSpPr/>
+        <p:nvPr/>
+      </p:nvGrpSpPr>
+      <p:grpSpPr>
+        <a:xfrm>
+          <a:off x="0" y="0"/>
+          <a:ext cx="0" cy="0"/>
+          <a:chOff x="0" y="0"/>
+          <a:chExt cx="0" cy="0"/>
+        </a:xfrm>
+      </p:grpSpPr>
+      <p:sp>
+        <p:nvSpPr>
+          <p:cNvPr id="2" name="Slide Image Placeholder 1"/>
+          <p:cNvSpPr>
+            <a:spLocks noGrp="1"/>
+          </p:cNvSpPr>
+          <p:nvPr>
+            <p:ph type="sldImg" idx="2"/>
+          </p:nvPr>
+        </p:nvSpPr>
+        <p:spPr/>
+      </p:sp>
+      <p:sp>
+        <p:nvSpPr>
+          <p:cNvPr id="3" name="Notes Placeholder 2"/>
+          <p:cNvSpPr>
+            <a:spLocks noGrp="1"/>
+          </p:cNvSpPr>
+          <p:nvPr>
+            <p:ph type="body" idx="3" sz="quarter"/>
+          </p:nvPr>
+        </p:nvSpPr>
+        <p:spPr/>
+        <p:txBody>
+          <a:bodyPr/>
+          <a:lstStyle/>
+          <a:p>
+            <a:r>
+              <a:t>Итоги. Первое: главные риски на объектах ВИЭ: электричество, высота и огонь. Второе: постоянный ток на панелях опасен, пока на них падает свет. Третье: работы только по наряду, с блокировкой и проверкой отсутствия напряжения. Четвёртое: высота требует допуска, СИЗ и плана спасения. Пятое: нужно знать знаки безопасности и порядок действий при аварии. Чистая энергия безопасна, когда безопасна работа с ней. Спасибо за внимание!</a:t>
+            </a:r>
+          </a:p>
+        </p:txBody>
+      </p:sp>
+      <p:sp>
+        <p:nvSpPr>
+          <p:cNvPr id="4" name="Slide Number Placeholder 3"/>
+          <p:cNvSpPr>
+            <a:spLocks noGrp="1"/>
+          </p:cNvSpPr>
+          <p:nvPr>
+            <p:ph type="sldNum" idx="5" sz="quarter"/>
+          </p:nvPr>
+        </p:nvSpPr>
+        <p:spPr/>
+      </p:sp>
+    </p:spTree>
+  </p:cSld>
+  <p:clrMapOvr>
+    <a:masterClrMapping/>
+  </p:clrMapOvr>
+</p:notes>
+</file>
+
+<file path=ppt/notesSlides/notesSlide29.xml><?xml version="1.0" encoding="utf-8"?>
 <p:notes xmlns:a="http://schemas.openxmlformats.org/drawingml/2006/main" xmlns:p="http://schemas.openxmlformats.org/presentationml/2006/main" xmlns:r="http://schemas.openxmlformats.org/officeDocument/2006/relationships">
   <p:cSld>
     <p:spTree>
@@ -7099,7 +7312,7 @@
                 </a:solidFill>
                 <a:latin typeface="Calibri"/>
               </a:rPr>
-              <a:t>Ветроустановки</a:t>
+              <a:t>Ветряки и накопители</a:t>
             </a:r>
           </a:p>
         </p:txBody>
@@ -7233,7 +7446,7 @@
                 </a:solidFill>
                 <a:latin typeface="Calibri"/>
               </a:rPr>
-              <a:t>Работа на высоте</a:t>
+              <a:t>Высота, допуск, СИЗ</a:t>
             </a:r>
           </a:p>
         </p:txBody>
@@ -7300,7 +7513,7 @@
                 </a:solidFill>
                 <a:latin typeface="Calibri"/>
               </a:rPr>
-              <a:t>СИЗ, знаки, аварии</a:t>
+              <a:t>Порядок и аварии</a:t>
             </a:r>
           </a:p>
         </p:txBody>
@@ -7615,7 +7828,7 @@
                           </a:solidFill>
                           <a:latin typeface="Calibri"/>
                         </a:rPr>
-                        <a:t>Постоянное напряжение до 1500 В, дуговой разряд, пожар, жара, падение с крыши</a:t>
+                        <a:t>Постоянное напряжение до 1500 В, дуговой разряд, пожар модулей и кабелей, нагрев поверхностей в жару, падение с крыши и скольжение по мокрым панелям</a:t>
                       </a:r>
                     </a:p>
                   </a:txBody>
@@ -7638,7 +7851,7 @@
                           </a:solidFill>
                           <a:latin typeface="Calibri"/>
                         </a:rPr>
-                        <a:t>Отключение, проверка отсутствия напряжения, страховка</a:t>
+                        <a:t>Отключение цепей, проверка отсутствия напряжения прибором, страховка, работа только по наряду и в паре</a:t>
                       </a:r>
                     </a:p>
                   </a:txBody>
@@ -7686,7 +7899,7 @@
                           </a:solidFill>
                           <a:latin typeface="Calibri"/>
                         </a:rPr>
-                        <a:t>Высота 80–120 м, вращающиеся части, обледенение, молния, пожар в гондоле</a:t>
+                        <a:t>Высота башни 80–120 м, вращающиеся части и внезапный запуск, обледенение лопастей, молния, пожар в гондоле, тесные рабочие места и один путь эвакуации</a:t>
                       </a:r>
                     </a:p>
                   </a:txBody>
@@ -7709,7 +7922,7 @@
                           </a:solidFill>
                           <a:latin typeface="Calibri"/>
                         </a:rPr>
-                        <a:t>Остановка и блокировка, допуск к работе на высоте, запретная зона</a:t>
+                        <a:t>Остановка и блокировка установки, допуск к работе на высоте, запретная зона при обледенении, план спасения</a:t>
                       </a:r>
                     </a:p>
                   </a:txBody>
@@ -7757,7 +7970,7 @@
                           </a:solidFill>
                           <a:latin typeface="Calibri"/>
                         </a:rPr>
-                        <a:t>Пожар и тепловой разгон литиевых батарей, токсичный дым, токи короткого замыкания</a:t>
+                        <a:t>Тепловой разгон литиевых батарей, пожар с выделением токсичного дыма, большие токи короткого замыкания, электролит и газы при повреждении</a:t>
                       </a:r>
                     </a:p>
                   </a:txBody>
@@ -7780,7 +7993,7 @@
                           </a:solidFill>
                           <a:latin typeface="Calibri"/>
                         </a:rPr>
-                        <a:t>Контроль температуры, вентиляция, автоматика пожаротушения</a:t>
+                        <a:t>Контроль температуры, вентиляция, автоматическое пожаротушение, дистанция между секциями</a:t>
                       </a:r>
                     </a:p>
                   </a:txBody>
@@ -7828,7 +8041,7 @@
                           </a:solidFill>
                           <a:latin typeface="Calibri"/>
                         </a:rPr>
-                        <a:t>Высокое напряжение, шаговое напряжение, обратное питание из сети</a:t>
+                        <a:t>Высокое напряжение, шаговое напряжение при замыкании на землю, обратное питание из сети, повреждение кабелей техникой</a:t>
                       </a:r>
                     </a:p>
                   </a:txBody>
@@ -7851,7 +8064,7 @@
                           </a:solidFill>
                           <a:latin typeface="Calibri"/>
                         </a:rPr>
-                        <a:t>Допуск, заземление, диэлектрические СИЗ</a:t>
+                        <a:t>Допуск по группе электробезопасности, заземление, диэлектрические СИЗ, ограждение зон</a:t>
                       </a:r>
                     </a:p>
                   </a:txBody>
@@ -8264,7 +8477,7 @@
                 </a:solidFill>
                 <a:latin typeface="Calibri"/>
               </a:rPr>
-              <a:t>Пока на панели падает свет, она вырабатывает напряжение; выключатель отключает только часть цепи</a:t>
+              <a:t>Пока на панель падает свет, она вырабатывает напряжение. Выключатель отключает только часть цепи, кабели постоянного тока остаются под напряжением</a:t>
             </a:r>
           </a:p>
         </p:txBody>
@@ -8433,7 +8646,7 @@
                 </a:solidFill>
                 <a:latin typeface="Calibri"/>
               </a:rPr>
-              <a:t>Плохой контакт даёт дуговой разряд на постоянном токе; он горит, пока есть питание</a:t>
+              <a:t>Плохой контакт разъёма даёт дуговой разряд. На постоянном токе дуга горит устойчиво, пока есть питание, и быстро поджигает кабели и модули</a:t>
             </a:r>
           </a:p>
         </p:txBody>
@@ -8602,7 +8815,7 @@
                 </a:solidFill>
                 <a:latin typeface="Calibri"/>
               </a:rPr>
-              <a:t>Падение с высоты, скользкая поверхность, острые кромки рам, работа в жару</a:t>
+              <a:t>Падение с кровли, скользкая мокрая или заснеженная поверхность, острые кромки рам, тепловой удар в жару. Модуль нельзя использовать как опору</a:t>
             </a:r>
           </a:p>
         </p:txBody>
@@ -8771,7 +8984,7 @@
                 </a:solidFill>
                 <a:latin typeface="Calibri"/>
               </a:rPr>
-              <a:t>Воду на электроустановку под напряжением подавать нельзя; нужны специальные средства</a:t>
+              <a:t>Воду на электроустановку под напряжением подавать нельзя. Нужны углекислотные и порошковые средства, а тушить нужно с безопасной дистанции</a:t>
             </a:r>
           </a:p>
         </p:txBody>
@@ -9431,7 +9644,7 @@
                 </a:solidFill>
                 <a:latin typeface="Calibri"/>
               </a:rPr>
-              <a:t>постоянный ток труднее погасить, чем переменный</a:t>
+              <a:t>на постоянном токе дуга горит устойчиво и не гаснет сама, ожоги и пожар</a:t>
             </a:r>
           </a:p>
         </p:txBody>
@@ -9521,7 +9734,7 @@
                 </a:solidFill>
                 <a:latin typeface="Calibri"/>
               </a:rPr>
-              <a:t>напряжение может прийти из сети или от панелей</a:t>
+              <a:t>напряжение может прийти из сети или от соседних панелей при отключении</a:t>
             </a:r>
           </a:p>
         </p:txBody>
@@ -9611,7 +9824,7 @@
                 </a:solidFill>
                 <a:latin typeface="Calibri"/>
               </a:rPr>
-              <a:t>конденсаторы инверторов держат напряжение</a:t>
+              <a:t>конденсаторы инвертора держат опасное напряжение ещё несколько минут</a:t>
             </a:r>
           </a:p>
         </p:txBody>
@@ -9701,7 +9914,7 @@
                 </a:solidFill>
                 <a:latin typeface="Calibri"/>
               </a:rPr>
-              <a:t>мокрый кабель и трещины изоляции</a:t>
+              <a:t>мокрый кабель, трещины изоляции и неисправные разъёмы дают утечку тока</a:t>
             </a:r>
           </a:p>
         </p:txBody>
@@ -9846,7 +10059,7 @@
                 </a:solidFill>
                 <a:latin typeface="Calibri"/>
               </a:rPr>
-              <a:t>работы по документу, с ответственным</a:t>
+              <a:t>работы по документу, с назначенным ответственным и допуском бригады</a:t>
             </a:r>
           </a:p>
         </p:txBody>
@@ -9936,7 +10149,7 @@
                 </a:solidFill>
                 <a:latin typeface="Calibri"/>
               </a:rPr>
-              <a:t>замок и бирка на каждом разъединителе</a:t>
+              <a:t>замок и бирка на каждом разъединителе, ключ остаётся у исполнителя</a:t>
             </a:r>
           </a:p>
         </p:txBody>
@@ -10026,7 +10239,7 @@
                 </a:solidFill>
                 <a:latin typeface="Calibri"/>
               </a:rPr>
-              <a:t>прибором, до касания и заземления</a:t>
+              <a:t>исправным прибором до касания, затем заземление и ограждение зоны</a:t>
             </a:r>
           </a:p>
         </p:txBody>
@@ -10116,7 +10329,7 @@
                 </a:solidFill>
                 <a:latin typeface="Calibri"/>
               </a:rPr>
-              <a:t>диэлектрический инструмент и перчатки</a:t>
+              <a:t>диэлектрические перчатки и боты, изолированный инструмент, щиток от дуги</a:t>
             </a:r>
           </a:p>
         </p:txBody>
@@ -10526,7 +10739,7 @@
               </a:spcAft>
             </a:pPr>
             <a:r>
-              <a:rPr sz="1600" b="1">
+              <a:rPr sz="1500" b="1">
                 <a:solidFill>
                   <a:srgbClr val="2B2B2B"/>
                 </a:solidFill>
@@ -10535,13 +10748,13 @@
               <a:t>Риск: </a:t>
             </a:r>
             <a:r>
-              <a:rPr sz="1600" b="0">
+              <a:rPr sz="1500" b="0">
                 <a:solidFill>
                   <a:srgbClr val="4B4B4B"/>
                 </a:solidFill>
                 <a:latin typeface="Calibri"/>
               </a:rPr>
-              <a:t>край крыши, скользкая поверхность, люк в гондоле</a:t>
+              <a:t>край крыши, скользкая поверхность, открытый люк гондолы</a:t>
             </a:r>
           </a:p>
           <a:p>
@@ -10551,7 +10764,7 @@
               </a:spcAft>
             </a:pPr>
             <a:r>
-              <a:rPr sz="1600" b="1">
+              <a:rPr sz="1500" b="1">
                 <a:solidFill>
                   <a:srgbClr val="2B2B2B"/>
                 </a:solidFill>
@@ -10560,13 +10773,13 @@
               <a:t>Мера: </a:t>
             </a:r>
             <a:r>
-              <a:rPr sz="1600" b="0">
+              <a:rPr sz="1500" b="0">
                 <a:solidFill>
                   <a:srgbClr val="4B4B4B"/>
                 </a:solidFill>
                 <a:latin typeface="Calibri"/>
               </a:rPr>
-              <a:t>ограждения, анкерные линии, страховочная привязь с двумя лонжами</a:t>
+              <a:t>ограждения, анкерные линии, привязь с двумя лонжами, пристёгивание на всём пути</a:t>
             </a:r>
           </a:p>
           <a:p>
@@ -10576,7 +10789,7 @@
               </a:spcAft>
             </a:pPr>
             <a:r>
-              <a:rPr sz="1600" b="1">
+              <a:rPr sz="1500" b="1">
                 <a:solidFill>
                   <a:srgbClr val="2B2B2B"/>
                 </a:solidFill>
@@ -10585,7 +10798,7 @@
               <a:t>Контроль: </a:t>
             </a:r>
             <a:r>
-              <a:rPr sz="1600" b="0">
+              <a:rPr sz="1500" b="0">
                 <a:solidFill>
                   <a:srgbClr val="4B4B4B"/>
                 </a:solidFill>
@@ -10758,7 +10971,7 @@
               </a:spcAft>
             </a:pPr>
             <a:r>
-              <a:rPr sz="1600" b="1">
+              <a:rPr sz="1500" b="1">
                 <a:solidFill>
                   <a:srgbClr val="2B2B2B"/>
                 </a:solidFill>
@@ -10767,7 +10980,7 @@
               <a:t>Риск: </a:t>
             </a:r>
             <a:r>
-              <a:rPr sz="1600" b="0">
+              <a:rPr sz="1500" b="0">
                 <a:solidFill>
                   <a:srgbClr val="4B4B4B"/>
                 </a:solidFill>
@@ -10783,7 +10996,7 @@
               </a:spcAft>
             </a:pPr>
             <a:r>
-              <a:rPr sz="1600" b="1">
+              <a:rPr sz="1500" b="1">
                 <a:solidFill>
                   <a:srgbClr val="2B2B2B"/>
                 </a:solidFill>
@@ -10792,13 +11005,13 @@
               <a:t>Мера: </a:t>
             </a:r>
             <a:r>
-              <a:rPr sz="1600" b="0">
+              <a:rPr sz="1500" b="0">
                 <a:solidFill>
                   <a:srgbClr val="4B4B4B"/>
                 </a:solidFill>
                 <a:latin typeface="Calibri"/>
               </a:rPr>
-              <a:t>набор для эвакуации и обученная группа спасения</a:t>
+              <a:t>набор для эвакуации, обученная группа спасения, связь с диспетчером</a:t>
             </a:r>
           </a:p>
           <a:p>
@@ -10808,7 +11021,7 @@
               </a:spcAft>
             </a:pPr>
             <a:r>
-              <a:rPr sz="1600" b="1">
+              <a:rPr sz="1500" b="1">
                 <a:solidFill>
                   <a:srgbClr val="2B2B2B"/>
                 </a:solidFill>
@@ -10817,7 +11030,7 @@
               <a:t>Контроль: </a:t>
             </a:r>
             <a:r>
-              <a:rPr sz="1600" b="0">
+              <a:rPr sz="1500" b="0">
                 <a:solidFill>
                   <a:srgbClr val="4B4B4B"/>
                 </a:solidFill>
@@ -10990,7 +11203,7 @@
               </a:spcAft>
             </a:pPr>
             <a:r>
-              <a:rPr sz="1600" b="1">
+              <a:rPr sz="1500" b="1">
                 <a:solidFill>
                   <a:srgbClr val="2B2B2B"/>
                 </a:solidFill>
@@ -10999,13 +11212,13 @@
               <a:t>Риск: </a:t>
             </a:r>
             <a:r>
-              <a:rPr sz="1600" b="0">
+              <a:rPr sz="1500" b="0">
                 <a:solidFill>
                   <a:srgbClr val="4B4B4B"/>
                 </a:solidFill>
                 <a:latin typeface="Calibri"/>
               </a:rPr>
-              <a:t>сильный ветер, гроза, лёд, жара и солнце</a:t>
+              <a:t>сильный ветер, гроза, лёд на конструкциях, жара и солнце</a:t>
             </a:r>
           </a:p>
           <a:p>
@@ -11015,7 +11228,7 @@
               </a:spcAft>
             </a:pPr>
             <a:r>
-              <a:rPr sz="1600" b="1">
+              <a:rPr sz="1500" b="1">
                 <a:solidFill>
                   <a:srgbClr val="2B2B2B"/>
                 </a:solidFill>
@@ -11024,13 +11237,13 @@
               <a:t>Мера: </a:t>
             </a:r>
             <a:r>
-              <a:rPr sz="1600" b="0">
+              <a:rPr sz="1500" b="0">
                 <a:solidFill>
                   <a:srgbClr val="4B4B4B"/>
                 </a:solidFill>
                 <a:latin typeface="Calibri"/>
               </a:rPr>
-              <a:t>запрет подъёма при превышении пределов из инструкции</a:t>
+              <a:t>запрет подъёма при превышении пределов из инструкции, перерывы в жару</a:t>
             </a:r>
           </a:p>
           <a:p>
@@ -11040,7 +11253,7 @@
               </a:spcAft>
             </a:pPr>
             <a:r>
-              <a:rPr sz="1600" b="1">
+              <a:rPr sz="1500" b="1">
                 <a:solidFill>
                   <a:srgbClr val="2B2B2B"/>
                 </a:solidFill>
@@ -11049,13 +11262,13 @@
               <a:t>Контроль: </a:t>
             </a:r>
             <a:r>
-              <a:rPr sz="1600" b="0">
+              <a:rPr sz="1500" b="0">
                 <a:solidFill>
                   <a:srgbClr val="4B4B4B"/>
                 </a:solidFill>
                 <a:latin typeface="Calibri"/>
               </a:rPr>
-              <a:t>прогноз и замер ветра перед работой</a:t>
+              <a:t>прогноз и замер ветра перед каждой работой</a:t>
             </a:r>
           </a:p>
         </p:txBody>
@@ -11425,7 +11638,7 @@
                           </a:solidFill>
                           <a:latin typeface="Calibri"/>
                         </a:rPr>
-                        <a:t>Каска с подбородочным ремнём</a:t>
+                        <a:t>Каска с подбородочным ремнём; под ней при холоде — тонкий подшлемник</a:t>
                       </a:r>
                     </a:p>
                   </a:txBody>
@@ -11448,7 +11661,7 @@
                           </a:solidFill>
                           <a:latin typeface="Calibri"/>
                         </a:rPr>
-                        <a:t>Удар, падающие предметы</a:t>
+                        <a:t>Удар, падающие предметы, касание конструкций</a:t>
                       </a:r>
                     </a:p>
                   </a:txBody>
@@ -11496,7 +11709,7 @@
                           </a:solidFill>
                           <a:latin typeface="Calibri"/>
                         </a:rPr>
-                        <a:t>Страховочная привязь, лонжи, анкерные точки</a:t>
+                        <a:t>Страховочная привязь, две лонжи с амортизатором, анкерные точки и каски</a:t>
                       </a:r>
                     </a:p>
                   </a:txBody>
@@ -11519,7 +11732,7 @@
                           </a:solidFill>
                           <a:latin typeface="Calibri"/>
                         </a:rPr>
-                        <a:t>Падение с высоты</a:t>
+                        <a:t>Падение с высоты, повисание</a:t>
                       </a:r>
                     </a:p>
                   </a:txBody>
@@ -11780,7 +11993,7 @@
                           </a:solidFill>
                           <a:latin typeface="Calibri"/>
                         </a:rPr>
-                        <a:t>Головной убор, очки от солнца, запас воды</a:t>
+                        <a:t>Головной убор, очки от солнца, питьевая вода, тёплая одежда в холодное время</a:t>
                       </a:r>
                     </a:p>
                   </a:txBody>
@@ -11803,7 +12016,7 @@
                           </a:solidFill>
                           <a:latin typeface="Calibri"/>
                         </a:rPr>
-                        <a:t>Жара, ультрафиолет</a:t>
+                        <a:t>Жара, ультрафиолет, переохлаждение</a:t>
                       </a:r>
                     </a:p>
                   </a:txBody>
@@ -12206,7 +12419,7 @@
                           </a:solidFill>
                           <a:latin typeface="Calibri"/>
                         </a:rPr>
-                        <a:t>Оформить документ, провести инструктаж, назначить ответственного и страхующего</a:t>
+                        <a:t>Оформить документ, провести целевой инструктаж, назначить ответственного руководителя работ и страхующего</a:t>
                       </a:r>
                     </a:p>
                   </a:txBody>
@@ -12277,7 +12490,7 @@
                           </a:solidFill>
                           <a:latin typeface="Calibri"/>
                         </a:rPr>
-                        <a:t>Проверить ветер, грозу, обледенение, жару и освещение</a:t>
+                        <a:t>Проверить ветер, грозу, обледенение, жару, освещение и состояние путей подхода к рабочему месту</a:t>
                       </a:r>
                     </a:p>
                   </a:txBody>
@@ -12348,7 +12561,7 @@
                           </a:solidFill>
                           <a:latin typeface="Calibri"/>
                         </a:rPr>
-                        <a:t>Отключить цепи, повесить замок и бирку на разъединители</a:t>
+                        <a:t>Отключить цепи, разомкнуть разъединители, повесить замок и бирку, вывесить плакат «Не включать»</a:t>
                       </a:r>
                     </a:p>
                   </a:txBody>
@@ -12419,7 +12632,7 @@
                           </a:solidFill>
                           <a:latin typeface="Calibri"/>
                         </a:rPr>
-                        <a:t>Убедиться прибором, что напряжения нет; панели днём всегда остаются под напряжением</a:t>
+                        <a:t>Убедиться исправным прибором, что напряжения нет; панели днём всегда остаются под напряжением, поэтому закрывают их или работают по правилам для цепей постоянного тока</a:t>
                       </a:r>
                     </a:p>
                   </a:txBody>
@@ -12490,7 +12703,7 @@
                           </a:solidFill>
                           <a:latin typeface="Calibri"/>
                         </a:rPr>
-                        <a:t>Работать вдвоём, держать связь, использовать страховку</a:t>
+                        <a:t>Работать вдвоём, держать связь с диспетчером, использовать страховку и не отвлекаться от задачи</a:t>
                       </a:r>
                     </a:p>
                   </a:txBody>
@@ -12561,7 +12774,7 @@
                           </a:solidFill>
                           <a:latin typeface="Calibri"/>
                         </a:rPr>
-                        <a:t>Собрать людей, снять блокировки, включать только по команде ответственного</a:t>
+                        <a:t>Собрать людей и инструмент, снять блокировки, закрыть наряд и включать только по команде ответственного</a:t>
                       </a:r>
                     </a:p>
                   </a:txBody>
@@ -13156,7 +13369,7 @@
                 </a:solidFill>
                 <a:latin typeface="Calibri"/>
               </a:rPr>
-              <a:t>постоянный ток до 1500 В</a:t>
+              <a:t>постоянный ток до 1500 В, не выключить при свете</a:t>
             </a:r>
           </a:p>
           <a:p>
@@ -13181,7 +13394,7 @@
                 </a:solidFill>
                 <a:latin typeface="Calibri"/>
               </a:rPr>
-              <a:t>заряд конденсаторов</a:t>
+              <a:t>заряд конденсаторов, время на разряд</a:t>
             </a:r>
           </a:p>
           <a:p>
@@ -13206,7 +13419,7 @@
                 </a:solidFill>
                 <a:latin typeface="Calibri"/>
               </a:rPr>
-              <a:t>высокое напряжение</a:t>
+              <a:t>высокое напряжение, допуск обязателен</a:t>
             </a:r>
           </a:p>
           <a:p>
@@ -13231,7 +13444,7 @@
                 </a:solidFill>
                 <a:latin typeface="Calibri"/>
               </a:rPr>
-              <a:t>обратное питание</a:t>
+              <a:t>обратное питание, заземление</a:t>
             </a:r>
           </a:p>
         </p:txBody>
@@ -13279,7 +13492,7 @@
                 </a:solidFill>
                 <a:latin typeface="Calibri"/>
               </a:rPr>
-              <a:t>крыша, башня, гондола</a:t>
+              <a:t>крыша, башня, люк гондолы</a:t>
             </a:r>
           </a:p>
           <a:p>
@@ -13304,7 +13517,7 @@
                 </a:solidFill>
                 <a:latin typeface="Calibri"/>
               </a:rPr>
-              <a:t>дуга, касание, обратное питание</a:t>
+              <a:t>дуга, касание, обратное питание, шаговое напряжение</a:t>
             </a:r>
           </a:p>
           <a:p>
@@ -13329,7 +13542,7 @@
                 </a:solidFill>
                 <a:latin typeface="Calibri"/>
               </a:rPr>
-              <a:t>панели, батареи, гондола</a:t>
+              <a:t>панели, кабели, батареи, гондола</a:t>
             </a:r>
           </a:p>
           <a:p>
@@ -13354,7 +13567,7 @@
                 </a:solidFill>
                 <a:latin typeface="Calibri"/>
               </a:rPr>
-              <a:t>ветер, гроза, лёд, жара</a:t>
+              <a:t>ветер, гроза, лёд, жара, плохая видимость</a:t>
             </a:r>
           </a:p>
         </p:txBody>
@@ -14424,6 +14637,861 @@
                 <a:latin typeface="Calibri"/>
               </a:rPr>
               <a:t>Числовые параметры на слайдах — ориентир; реквизиты документов и значения сверяйте с действующими редакциями.</a:t>
+            </a:r>
+          </a:p>
+        </p:txBody>
+      </p:sp>
+    </p:spTree>
+    <p:extLst>
+      <p:ext uri="{BB962C8B-B14F-4D97-AF65-F5344CB8AC3E}">
+        <p14:creationId xmlns:p14="http://schemas.microsoft.com/office/powerpoint/2010/main" val="527513127"/>
+      </p:ext>
+    </p:extLst>
+  </p:cSld>
+  <p:clrMapOvr>
+    <a:masterClrMapping/>
+  </p:clrMapOvr>
+</p:sld>
+</file>
+
+<file path=ppt/slides/slide31.xml><?xml version="1.0" encoding="utf-8"?>
+<p:sld xmlns:a="http://schemas.openxmlformats.org/drawingml/2006/main" xmlns:r="http://schemas.openxmlformats.org/officeDocument/2006/relationships" xmlns:p="http://schemas.openxmlformats.org/presentationml/2006/main">
+  <p:cSld>
+    <p:spTree>
+      <p:nvGrpSpPr>
+        <p:cNvPr id="1" name=""/>
+        <p:cNvGrpSpPr/>
+        <p:nvPr/>
+      </p:nvGrpSpPr>
+      <p:grpSpPr>
+        <a:xfrm>
+          <a:off x="0" y="0"/>
+          <a:ext cx="0" cy="0"/>
+          <a:chOff x="0" y="0"/>
+          <a:chExt cx="0" cy="0"/>
+        </a:xfrm>
+      </p:grpSpPr>
+      <p:sp>
+        <p:nvSpPr>
+          <p:cNvPr id="2" name="Заголовок 1"/>
+          <p:cNvSpPr>
+            <a:spLocks noGrp="1"/>
+          </p:cNvSpPr>
+          <p:nvPr>
+            <p:ph type="title"/>
+          </p:nvPr>
+        </p:nvSpPr>
+        <p:spPr>
+          <a:xfrm>
+            <a:off x="407988" y="765175"/>
+            <a:ext cx="10515600" cy="681885"/>
+          </a:xfrm>
+        </p:spPr>
+        <p:txBody>
+          <a:bodyPr>
+            <a:normAutofit/>
+          </a:bodyPr>
+          <a:lstStyle/>
+          <a:p>
+            <a:r>
+              <a:rPr lang="ru-RU" sz="2800" b="1" dirty="0">
+                <a:solidFill>
+                  <a:schemeClr val="tx1">
+                    <a:lumMod val="85000"/>
+                    <a:lumOff val="15000"/>
+                  </a:schemeClr>
+                </a:solidFill>
+                <a:latin typeface="+mn-lt"/>
+              </a:rPr>
+              <a:t>Накопители энергии: литиевые аккумуляторы</a:t>
+            </a:r>
+          </a:p>
+        </p:txBody>
+      </p:sp>
+      <p:sp>
+        <p:nvSpPr>
+          <p:cNvPr id="6" name="Прямоугольник 5"/>
+          <p:cNvSpPr/>
+          <p:nvPr/>
+        </p:nvSpPr>
+        <p:spPr>
+          <a:xfrm>
+            <a:off x="8330738" y="132112"/>
+            <a:ext cx="3473334" cy="338554"/>
+          </a:xfrm>
+          <a:prstGeom prst="rect">
+            <a:avLst/>
+          </a:prstGeom>
+        </p:spPr>
+        <p:txBody>
+          <a:bodyPr wrap="square">
+            <a:spAutoFit/>
+          </a:bodyPr>
+          <a:lstStyle/>
+          <a:p>
+            <a:pPr lvl="0" algn="r"/>
+            <a:r>
+              <a:rPr lang="ru-RU" sz="1600" b="1" dirty="0">
+                <a:solidFill>
+                  <a:schemeClr val="bg1"/>
+                </a:solidFill>
+              </a:rPr>
+              <a:t>ВИЭ: БЕЗОПАСНОСТЬ</a:t>
+            </a:r>
+          </a:p>
+        </p:txBody>
+      </p:sp>
+      <p:sp>
+        <p:nvSpPr>
+          <p:cNvPr id="8" name="Прямоугольник 7"/>
+          <p:cNvSpPr/>
+          <p:nvPr/>
+        </p:nvSpPr>
+        <p:spPr>
+          <a:xfrm>
+            <a:off x="0" y="-2992"/>
+            <a:ext cx="12192000" cy="571403"/>
+          </a:xfrm>
+          <a:prstGeom prst="rect">
+            <a:avLst/>
+          </a:prstGeom>
+          <a:solidFill>
+            <a:schemeClr val="tx1">
+              <a:lumMod val="85000"/>
+              <a:lumOff val="15000"/>
+            </a:schemeClr>
+          </a:solidFill>
+          <a:ln>
+            <a:noFill/>
+          </a:ln>
+        </p:spPr>
+        <p:style>
+          <a:lnRef idx="2">
+            <a:schemeClr val="accent1">
+              <a:shade val="50000"/>
+            </a:schemeClr>
+          </a:lnRef>
+          <a:fillRef idx="1">
+            <a:schemeClr val="accent1"/>
+          </a:fillRef>
+          <a:effectRef idx="0">
+            <a:schemeClr val="accent1"/>
+          </a:effectRef>
+          <a:fontRef idx="minor">
+            <a:schemeClr val="lt1"/>
+          </a:fontRef>
+        </p:style>
+        <p:txBody>
+          <a:bodyPr rtlCol="0" anchor="ctr"/>
+          <a:lstStyle/>
+          <a:p>
+            <a:pPr algn="ctr"/>
+            <a:endParaRPr lang="ru-RU"/>
+          </a:p>
+        </p:txBody>
+      </p:sp>
+      <p:pic>
+        <p:nvPicPr>
+          <p:cNvPr id="9" name="Рисунок 8"/>
+          <p:cNvPicPr>
+            <a:picLocks noChangeAspect="1"/>
+          </p:cNvPicPr>
+          <p:nvPr/>
+        </p:nvPicPr>
+        <p:blipFill>
+          <a:blip r:embed="rId2" cstate="print">
+            <a:extLst>
+              <a:ext uri="{28A0092B-C50C-407E-A947-70E740481C1C}">
+                <a14:useLocalDpi xmlns:a14="http://schemas.microsoft.com/office/drawing/2010/main" val="0"/>
+              </a:ext>
+            </a:extLst>
+          </a:blip>
+          <a:stretch>
+            <a:fillRect/>
+          </a:stretch>
+        </p:blipFill>
+        <p:spPr>
+          <a:xfrm>
+            <a:off x="396995" y="141442"/>
+            <a:ext cx="3185962" cy="351041"/>
+          </a:xfrm>
+          <a:prstGeom prst="rect">
+            <a:avLst/>
+          </a:prstGeom>
+        </p:spPr>
+      </p:pic>
+      <p:sp>
+        <p:nvSpPr>
+          <p:cNvPr id="10" name="Блок 1"/>
+          <p:cNvSpPr/>
+          <p:nvPr/>
+        </p:nvSpPr>
+        <p:spPr>
+          <a:xfrm>
+            <a:off x="594360" y="1691640"/>
+            <a:ext cx="5394960" cy="2103120"/>
+          </a:xfrm>
+          <a:prstGeom prst="roundRect">
+            <a:avLst>
+              <a:gd name="adj" fmla="val 8000"/>
+            </a:avLst>
+          </a:prstGeom>
+          <a:solidFill>
+            <a:srgbClr val="F1F1F1"/>
+          </a:solidFill>
+          <a:ln>
+            <a:noFill/>
+          </a:ln>
+          <a:effectLst/>
+        </p:spPr>
+        <p:style>
+          <a:lnRef idx="1">
+            <a:schemeClr val="accent1"/>
+          </a:lnRef>
+          <a:fillRef idx="3">
+            <a:schemeClr val="accent1"/>
+          </a:fillRef>
+          <a:effectRef idx="2">
+            <a:schemeClr val="accent1"/>
+          </a:effectRef>
+          <a:fontRef idx="minor">
+            <a:schemeClr val="lt1"/>
+          </a:fontRef>
+        </p:style>
+        <p:txBody>
+          <a:bodyPr rtlCol="0" anchor="ctr"/>
+          <a:lstStyle/>
+          <a:p>
+            <a:pPr algn="ctr"/>
+          </a:p>
+        </p:txBody>
+      </p:sp>
+      <p:sp>
+        <p:nvSpPr>
+          <p:cNvPr id="11" name="Oval 10"/>
+          <p:cNvSpPr/>
+          <p:nvPr/>
+        </p:nvSpPr>
+        <p:spPr>
+          <a:xfrm>
+            <a:off x="758952" y="1856231"/>
+            <a:ext cx="402336" cy="402336"/>
+          </a:xfrm>
+          <a:prstGeom prst="ellipse">
+            <a:avLst/>
+          </a:prstGeom>
+          <a:solidFill>
+            <a:srgbClr val="FFED00"/>
+          </a:solidFill>
+          <a:ln>
+            <a:noFill/>
+          </a:ln>
+          <a:effectLst/>
+        </p:spPr>
+        <p:style>
+          <a:lnRef idx="1">
+            <a:schemeClr val="accent1"/>
+          </a:lnRef>
+          <a:fillRef idx="3">
+            <a:schemeClr val="accent1"/>
+          </a:fillRef>
+          <a:effectRef idx="2">
+            <a:schemeClr val="accent1"/>
+          </a:effectRef>
+          <a:fontRef idx="minor">
+            <a:schemeClr val="lt1"/>
+          </a:fontRef>
+        </p:style>
+        <p:txBody>
+          <a:bodyPr rtlCol="0" anchor="ctr" wrap="square" lIns="0" rIns="0" tIns="27432" bIns="27432"/>
+          <a:lstStyle/>
+          <a:p>
+            <a:pPr algn="ctr"/>
+            <a:r>
+              <a:rPr sz="1400" b="1">
+                <a:solidFill>
+                  <a:srgbClr val="2B2B2B"/>
+                </a:solidFill>
+                <a:latin typeface="Calibri"/>
+              </a:rPr>
+              <a:t>1</a:t>
+            </a:r>
+          </a:p>
+        </p:txBody>
+      </p:sp>
+      <p:sp>
+        <p:nvSpPr>
+          <p:cNvPr id="12" name="TextBox 11"/>
+          <p:cNvSpPr txBox="1"/>
+          <p:nvPr/>
+        </p:nvSpPr>
+        <p:spPr>
+          <a:xfrm>
+            <a:off x="1325880" y="1856232"/>
+            <a:ext cx="4480560" cy="411480"/>
+          </a:xfrm>
+          <a:prstGeom prst="rect">
+            <a:avLst/>
+          </a:prstGeom>
+          <a:noFill/>
+        </p:spPr>
+        <p:txBody>
+          <a:bodyPr wrap="square" anchor="ctr" lIns="18288" rIns="18288" tIns="27432" bIns="27432">
+            <a:spAutoFit/>
+          </a:bodyPr>
+          <a:lstStyle/>
+          <a:p>
+            <a:pPr algn="l"/>
+            <a:r>
+              <a:rPr sz="1600" b="1">
+                <a:solidFill>
+                  <a:srgbClr val="2B2B2B"/>
+                </a:solidFill>
+                <a:latin typeface="Calibri"/>
+              </a:rPr>
+              <a:t>Тепловой разгон</a:t>
+            </a:r>
+          </a:p>
+        </p:txBody>
+      </p:sp>
+      <p:sp>
+        <p:nvSpPr>
+          <p:cNvPr id="13" name="Блок 1 текст"/>
+          <p:cNvSpPr txBox="1"/>
+          <p:nvPr/>
+        </p:nvSpPr>
+        <p:spPr>
+          <a:xfrm>
+            <a:off x="777240" y="2423160"/>
+            <a:ext cx="5029200" cy="1325880"/>
+          </a:xfrm>
+          <a:prstGeom prst="rect">
+            <a:avLst/>
+          </a:prstGeom>
+          <a:noFill/>
+        </p:spPr>
+        <p:txBody>
+          <a:bodyPr wrap="square" anchor="t" lIns="18288" rIns="18288" tIns="27432" bIns="27432">
+            <a:spAutoFit/>
+          </a:bodyPr>
+          <a:lstStyle/>
+          <a:p>
+            <a:pPr algn="l"/>
+            <a:r>
+              <a:rPr sz="1500" b="0">
+                <a:solidFill>
+                  <a:srgbClr val="4B4B4B"/>
+                </a:solidFill>
+                <a:latin typeface="Calibri"/>
+              </a:rPr>
+              <a:t>Перегрев, перезаряд или повреждение запускают цепную реакцию нагрева. Ячейка за ячейкой воспламеняется, температура быстро растёт, а батарея может загореться повторно уже после тушения.</a:t>
+            </a:r>
+          </a:p>
+        </p:txBody>
+      </p:sp>
+      <p:sp>
+        <p:nvSpPr>
+          <p:cNvPr id="14" name="Блок 2"/>
+          <p:cNvSpPr/>
+          <p:nvPr/>
+        </p:nvSpPr>
+        <p:spPr>
+          <a:xfrm>
+            <a:off x="6217920" y="1691640"/>
+            <a:ext cx="5394960" cy="2103120"/>
+          </a:xfrm>
+          <a:prstGeom prst="roundRect">
+            <a:avLst>
+              <a:gd name="adj" fmla="val 8000"/>
+            </a:avLst>
+          </a:prstGeom>
+          <a:solidFill>
+            <a:srgbClr val="F1F1F1"/>
+          </a:solidFill>
+          <a:ln>
+            <a:noFill/>
+          </a:ln>
+          <a:effectLst/>
+        </p:spPr>
+        <p:style>
+          <a:lnRef idx="1">
+            <a:schemeClr val="accent1"/>
+          </a:lnRef>
+          <a:fillRef idx="3">
+            <a:schemeClr val="accent1"/>
+          </a:fillRef>
+          <a:effectRef idx="2">
+            <a:schemeClr val="accent1"/>
+          </a:effectRef>
+          <a:fontRef idx="minor">
+            <a:schemeClr val="lt1"/>
+          </a:fontRef>
+        </p:style>
+        <p:txBody>
+          <a:bodyPr rtlCol="0" anchor="ctr"/>
+          <a:lstStyle/>
+          <a:p>
+            <a:pPr algn="ctr"/>
+          </a:p>
+        </p:txBody>
+      </p:sp>
+      <p:sp>
+        <p:nvSpPr>
+          <p:cNvPr id="15" name="Oval 14"/>
+          <p:cNvSpPr/>
+          <p:nvPr/>
+        </p:nvSpPr>
+        <p:spPr>
+          <a:xfrm>
+            <a:off x="6382512" y="1856231"/>
+            <a:ext cx="402336" cy="402336"/>
+          </a:xfrm>
+          <a:prstGeom prst="ellipse">
+            <a:avLst/>
+          </a:prstGeom>
+          <a:solidFill>
+            <a:srgbClr val="FFED00"/>
+          </a:solidFill>
+          <a:ln>
+            <a:noFill/>
+          </a:ln>
+          <a:effectLst/>
+        </p:spPr>
+        <p:style>
+          <a:lnRef idx="1">
+            <a:schemeClr val="accent1"/>
+          </a:lnRef>
+          <a:fillRef idx="3">
+            <a:schemeClr val="accent1"/>
+          </a:fillRef>
+          <a:effectRef idx="2">
+            <a:schemeClr val="accent1"/>
+          </a:effectRef>
+          <a:fontRef idx="minor">
+            <a:schemeClr val="lt1"/>
+          </a:fontRef>
+        </p:style>
+        <p:txBody>
+          <a:bodyPr rtlCol="0" anchor="ctr" wrap="square" lIns="0" rIns="0" tIns="27432" bIns="27432"/>
+          <a:lstStyle/>
+          <a:p>
+            <a:pPr algn="ctr"/>
+            <a:r>
+              <a:rPr sz="1400" b="1">
+                <a:solidFill>
+                  <a:srgbClr val="2B2B2B"/>
+                </a:solidFill>
+                <a:latin typeface="Calibri"/>
+              </a:rPr>
+              <a:t>2</a:t>
+            </a:r>
+          </a:p>
+        </p:txBody>
+      </p:sp>
+      <p:sp>
+        <p:nvSpPr>
+          <p:cNvPr id="16" name="TextBox 15"/>
+          <p:cNvSpPr txBox="1"/>
+          <p:nvPr/>
+        </p:nvSpPr>
+        <p:spPr>
+          <a:xfrm>
+            <a:off x="6949440" y="1856232"/>
+            <a:ext cx="4480560" cy="411480"/>
+          </a:xfrm>
+          <a:prstGeom prst="rect">
+            <a:avLst/>
+          </a:prstGeom>
+          <a:noFill/>
+        </p:spPr>
+        <p:txBody>
+          <a:bodyPr wrap="square" anchor="ctr" lIns="18288" rIns="18288" tIns="27432" bIns="27432">
+            <a:spAutoFit/>
+          </a:bodyPr>
+          <a:lstStyle/>
+          <a:p>
+            <a:pPr algn="l"/>
+            <a:r>
+              <a:rPr sz="1600" b="1">
+                <a:solidFill>
+                  <a:srgbClr val="2B2B2B"/>
+                </a:solidFill>
+                <a:latin typeface="Calibri"/>
+              </a:rPr>
+              <a:t>Токсичный дым и газы</a:t>
+            </a:r>
+          </a:p>
+        </p:txBody>
+      </p:sp>
+      <p:sp>
+        <p:nvSpPr>
+          <p:cNvPr id="17" name="Блок 2 текст"/>
+          <p:cNvSpPr txBox="1"/>
+          <p:nvPr/>
+        </p:nvSpPr>
+        <p:spPr>
+          <a:xfrm>
+            <a:off x="6400800" y="2423160"/>
+            <a:ext cx="5029200" cy="1325880"/>
+          </a:xfrm>
+          <a:prstGeom prst="rect">
+            <a:avLst/>
+          </a:prstGeom>
+          <a:noFill/>
+        </p:spPr>
+        <p:txBody>
+          <a:bodyPr wrap="square" anchor="t" lIns="18288" rIns="18288" tIns="27432" bIns="27432">
+            <a:spAutoFit/>
+          </a:bodyPr>
+          <a:lstStyle/>
+          <a:p>
+            <a:pPr algn="l"/>
+            <a:r>
+              <a:rPr sz="1500" b="0">
+                <a:solidFill>
+                  <a:srgbClr val="4B4B4B"/>
+                </a:solidFill>
+                <a:latin typeface="Calibri"/>
+              </a:rPr>
+              <a:t>При горении выделяются едкие и горючие газы, в том числе фтороводород. Входить в помещение без изолирующих средств защиты дыхания нельзя, вентиляцию продумывают заранее.</a:t>
+            </a:r>
+          </a:p>
+        </p:txBody>
+      </p:sp>
+      <p:sp>
+        <p:nvSpPr>
+          <p:cNvPr id="18" name="Блок 3"/>
+          <p:cNvSpPr/>
+          <p:nvPr/>
+        </p:nvSpPr>
+        <p:spPr>
+          <a:xfrm>
+            <a:off x="594360" y="3977639"/>
+            <a:ext cx="5394960" cy="2103120"/>
+          </a:xfrm>
+          <a:prstGeom prst="roundRect">
+            <a:avLst>
+              <a:gd name="adj" fmla="val 8000"/>
+            </a:avLst>
+          </a:prstGeom>
+          <a:solidFill>
+            <a:srgbClr val="F1F1F1"/>
+          </a:solidFill>
+          <a:ln>
+            <a:noFill/>
+          </a:ln>
+          <a:effectLst/>
+        </p:spPr>
+        <p:style>
+          <a:lnRef idx="1">
+            <a:schemeClr val="accent1"/>
+          </a:lnRef>
+          <a:fillRef idx="3">
+            <a:schemeClr val="accent1"/>
+          </a:fillRef>
+          <a:effectRef idx="2">
+            <a:schemeClr val="accent1"/>
+          </a:effectRef>
+          <a:fontRef idx="minor">
+            <a:schemeClr val="lt1"/>
+          </a:fontRef>
+        </p:style>
+        <p:txBody>
+          <a:bodyPr rtlCol="0" anchor="ctr"/>
+          <a:lstStyle/>
+          <a:p>
+            <a:pPr algn="ctr"/>
+          </a:p>
+        </p:txBody>
+      </p:sp>
+      <p:sp>
+        <p:nvSpPr>
+          <p:cNvPr id="19" name="Oval 18"/>
+          <p:cNvSpPr/>
+          <p:nvPr/>
+        </p:nvSpPr>
+        <p:spPr>
+          <a:xfrm>
+            <a:off x="758952" y="4142232"/>
+            <a:ext cx="402336" cy="402336"/>
+          </a:xfrm>
+          <a:prstGeom prst="ellipse">
+            <a:avLst/>
+          </a:prstGeom>
+          <a:solidFill>
+            <a:srgbClr val="FFED00"/>
+          </a:solidFill>
+          <a:ln>
+            <a:noFill/>
+          </a:ln>
+          <a:effectLst/>
+        </p:spPr>
+        <p:style>
+          <a:lnRef idx="1">
+            <a:schemeClr val="accent1"/>
+          </a:lnRef>
+          <a:fillRef idx="3">
+            <a:schemeClr val="accent1"/>
+          </a:fillRef>
+          <a:effectRef idx="2">
+            <a:schemeClr val="accent1"/>
+          </a:effectRef>
+          <a:fontRef idx="minor">
+            <a:schemeClr val="lt1"/>
+          </a:fontRef>
+        </p:style>
+        <p:txBody>
+          <a:bodyPr rtlCol="0" anchor="ctr" wrap="square" lIns="0" rIns="0" tIns="27432" bIns="27432"/>
+          <a:lstStyle/>
+          <a:p>
+            <a:pPr algn="ctr"/>
+            <a:r>
+              <a:rPr sz="1400" b="1">
+                <a:solidFill>
+                  <a:srgbClr val="2B2B2B"/>
+                </a:solidFill>
+                <a:latin typeface="Calibri"/>
+              </a:rPr>
+              <a:t>3</a:t>
+            </a:r>
+          </a:p>
+        </p:txBody>
+      </p:sp>
+      <p:sp>
+        <p:nvSpPr>
+          <p:cNvPr id="20" name="TextBox 19"/>
+          <p:cNvSpPr txBox="1"/>
+          <p:nvPr/>
+        </p:nvSpPr>
+        <p:spPr>
+          <a:xfrm>
+            <a:off x="1325880" y="4142231"/>
+            <a:ext cx="4480560" cy="411480"/>
+          </a:xfrm>
+          <a:prstGeom prst="rect">
+            <a:avLst/>
+          </a:prstGeom>
+          <a:noFill/>
+        </p:spPr>
+        <p:txBody>
+          <a:bodyPr wrap="square" anchor="ctr" lIns="18288" rIns="18288" tIns="27432" bIns="27432">
+            <a:spAutoFit/>
+          </a:bodyPr>
+          <a:lstStyle/>
+          <a:p>
+            <a:pPr algn="l"/>
+            <a:r>
+              <a:rPr sz="1600" b="1">
+                <a:solidFill>
+                  <a:srgbClr val="2B2B2B"/>
+                </a:solidFill>
+                <a:latin typeface="Calibri"/>
+              </a:rPr>
+              <a:t>Электрические опасности</a:t>
+            </a:r>
+          </a:p>
+        </p:txBody>
+      </p:sp>
+      <p:sp>
+        <p:nvSpPr>
+          <p:cNvPr id="21" name="Блок 3 текст"/>
+          <p:cNvSpPr txBox="1"/>
+          <p:nvPr/>
+        </p:nvSpPr>
+        <p:spPr>
+          <a:xfrm>
+            <a:off x="777240" y="4709159"/>
+            <a:ext cx="5029200" cy="1325880"/>
+          </a:xfrm>
+          <a:prstGeom prst="rect">
+            <a:avLst/>
+          </a:prstGeom>
+          <a:noFill/>
+        </p:spPr>
+        <p:txBody>
+          <a:bodyPr wrap="square" anchor="t" lIns="18288" rIns="18288" tIns="27432" bIns="27432">
+            <a:spAutoFit/>
+          </a:bodyPr>
+          <a:lstStyle/>
+          <a:p>
+            <a:pPr algn="l"/>
+            <a:r>
+              <a:rPr sz="1500" b="0">
+                <a:solidFill>
+                  <a:srgbClr val="4B4B4B"/>
+                </a:solidFill>
+                <a:latin typeface="Calibri"/>
+              </a:rPr>
+              <a:t>Даже отключённая батарея остаётся под напряжением. Короткое замыкание даёт огромные токи и дугу, поэтому работают изолированным инструментом и снимают металлические украшения.</a:t>
+            </a:r>
+          </a:p>
+        </p:txBody>
+      </p:sp>
+      <p:sp>
+        <p:nvSpPr>
+          <p:cNvPr id="22" name="Блок 4"/>
+          <p:cNvSpPr/>
+          <p:nvPr/>
+        </p:nvSpPr>
+        <p:spPr>
+          <a:xfrm>
+            <a:off x="6217920" y="3977639"/>
+            <a:ext cx="5394960" cy="2103120"/>
+          </a:xfrm>
+          <a:prstGeom prst="roundRect">
+            <a:avLst>
+              <a:gd name="adj" fmla="val 8000"/>
+            </a:avLst>
+          </a:prstGeom>
+          <a:solidFill>
+            <a:srgbClr val="F1F1F1"/>
+          </a:solidFill>
+          <a:ln>
+            <a:noFill/>
+          </a:ln>
+          <a:effectLst/>
+        </p:spPr>
+        <p:style>
+          <a:lnRef idx="1">
+            <a:schemeClr val="accent1"/>
+          </a:lnRef>
+          <a:fillRef idx="3">
+            <a:schemeClr val="accent1"/>
+          </a:fillRef>
+          <a:effectRef idx="2">
+            <a:schemeClr val="accent1"/>
+          </a:effectRef>
+          <a:fontRef idx="minor">
+            <a:schemeClr val="lt1"/>
+          </a:fontRef>
+        </p:style>
+        <p:txBody>
+          <a:bodyPr rtlCol="0" anchor="ctr"/>
+          <a:lstStyle/>
+          <a:p>
+            <a:pPr algn="ctr"/>
+          </a:p>
+        </p:txBody>
+      </p:sp>
+      <p:sp>
+        <p:nvSpPr>
+          <p:cNvPr id="23" name="Oval 22"/>
+          <p:cNvSpPr/>
+          <p:nvPr/>
+        </p:nvSpPr>
+        <p:spPr>
+          <a:xfrm>
+            <a:off x="6382512" y="4142232"/>
+            <a:ext cx="402336" cy="402336"/>
+          </a:xfrm>
+          <a:prstGeom prst="ellipse">
+            <a:avLst/>
+          </a:prstGeom>
+          <a:solidFill>
+            <a:srgbClr val="FFED00"/>
+          </a:solidFill>
+          <a:ln>
+            <a:noFill/>
+          </a:ln>
+          <a:effectLst/>
+        </p:spPr>
+        <p:style>
+          <a:lnRef idx="1">
+            <a:schemeClr val="accent1"/>
+          </a:lnRef>
+          <a:fillRef idx="3">
+            <a:schemeClr val="accent1"/>
+          </a:fillRef>
+          <a:effectRef idx="2">
+            <a:schemeClr val="accent1"/>
+          </a:effectRef>
+          <a:fontRef idx="minor">
+            <a:schemeClr val="lt1"/>
+          </a:fontRef>
+        </p:style>
+        <p:txBody>
+          <a:bodyPr rtlCol="0" anchor="ctr" wrap="square" lIns="0" rIns="0" tIns="27432" bIns="27432"/>
+          <a:lstStyle/>
+          <a:p>
+            <a:pPr algn="ctr"/>
+            <a:r>
+              <a:rPr sz="1400" b="1">
+                <a:solidFill>
+                  <a:srgbClr val="2B2B2B"/>
+                </a:solidFill>
+                <a:latin typeface="Calibri"/>
+              </a:rPr>
+              <a:t>4</a:t>
+            </a:r>
+          </a:p>
+        </p:txBody>
+      </p:sp>
+      <p:sp>
+        <p:nvSpPr>
+          <p:cNvPr id="24" name="TextBox 23"/>
+          <p:cNvSpPr txBox="1"/>
+          <p:nvPr/>
+        </p:nvSpPr>
+        <p:spPr>
+          <a:xfrm>
+            <a:off x="6949440" y="4142231"/>
+            <a:ext cx="4480560" cy="411480"/>
+          </a:xfrm>
+          <a:prstGeom prst="rect">
+            <a:avLst/>
+          </a:prstGeom>
+          <a:noFill/>
+        </p:spPr>
+        <p:txBody>
+          <a:bodyPr wrap="square" anchor="ctr" lIns="18288" rIns="18288" tIns="27432" bIns="27432">
+            <a:spAutoFit/>
+          </a:bodyPr>
+          <a:lstStyle/>
+          <a:p>
+            <a:pPr algn="l"/>
+            <a:r>
+              <a:rPr sz="1600" b="1">
+                <a:solidFill>
+                  <a:srgbClr val="2B2B2B"/>
+                </a:solidFill>
+                <a:latin typeface="Calibri"/>
+              </a:rPr>
+              <a:t>Меры защиты</a:t>
+            </a:r>
+          </a:p>
+        </p:txBody>
+      </p:sp>
+      <p:sp>
+        <p:nvSpPr>
+          <p:cNvPr id="25" name="Блок 4 текст"/>
+          <p:cNvSpPr txBox="1"/>
+          <p:nvPr/>
+        </p:nvSpPr>
+        <p:spPr>
+          <a:xfrm>
+            <a:off x="6400800" y="4709159"/>
+            <a:ext cx="5029200" cy="1325880"/>
+          </a:xfrm>
+          <a:prstGeom prst="rect">
+            <a:avLst/>
+          </a:prstGeom>
+          <a:noFill/>
+        </p:spPr>
+        <p:txBody>
+          <a:bodyPr wrap="square" anchor="t" lIns="18288" rIns="18288" tIns="27432" bIns="27432">
+            <a:spAutoFit/>
+          </a:bodyPr>
+          <a:lstStyle/>
+          <a:p>
+            <a:pPr algn="l"/>
+            <a:r>
+              <a:rPr sz="1500" b="0">
+                <a:solidFill>
+                  <a:srgbClr val="4B4B4B"/>
+                </a:solidFill>
+                <a:latin typeface="Calibri"/>
+              </a:rPr>
+              <a:t>Контроль температуры и напряжения каждого модуля, автоматическое пожаротушение, разделение секций, дистанция между контейнерами, план реагирования и обучение персонала.</a:t>
             </a:r>
           </a:p>
         </p:txBody>
@@ -14903,7 +15971,7 @@
                 </a:solidFill>
                 <a:latin typeface="Calibri"/>
               </a:rPr>
-              <a:t>Ветроустановка — это высота, вращающиеся части и электрооборудование в одном месте. Подъём и спуск занимают время, поэтому спасательные действия нужно продумать заранее.</a:t>
+              <a:t>Ветроустановка — это высота, вращающиеся части и электрооборудование в одном месте. Подъём и спуск занимают время, поэтому действия при аварии и спасение нужно продумать заранее. Перед работой установку останавливают, ротор фиксируют, а ответственный подтверждает, что запуск невозможен.</a:t>
             </a:r>
           </a:p>
         </p:txBody>
@@ -15032,7 +16100,7 @@
                 </a:solidFill>
                 <a:latin typeface="Calibri"/>
               </a:rPr>
-              <a:t>Падение с высоты при подъёме и работе в гондоле</a:t>
+              <a:t>Падение при подъёме по лестнице и работе в гондоле</a:t>
             </a:r>
           </a:p>
           <a:p>
@@ -15057,7 +16125,7 @@
                 </a:solidFill>
                 <a:latin typeface="Calibri"/>
               </a:rPr>
-              <a:t>Вращающиеся части и запуск без предупреждения</a:t>
+              <a:t>Вращающиеся части и внезапный запуск без предупреждения</a:t>
             </a:r>
           </a:p>
           <a:p>
@@ -15082,7 +16150,7 @@
                 </a:solidFill>
                 <a:latin typeface="Calibri"/>
               </a:rPr>
-              <a:t>Куски льда с лопастей и молния в грозу</a:t>
+              <a:t>Куски льда, слетающие с лопастей, и молния в грозу</a:t>
             </a:r>
           </a:p>
           <a:p>
@@ -15107,7 +16175,7 @@
                 </a:solidFill>
                 <a:latin typeface="Calibri"/>
               </a:rPr>
-              <a:t>Пожар в гондоле: путь эвакуации один</a:t>
+              <a:t>Пожар в гондоле, где путь эвакуации только один</a:t>
             </a:r>
           </a:p>
         </p:txBody>
@@ -15261,7 +16329,7 @@
                 </a:solidFill>
                 <a:latin typeface="Calibri"/>
               </a:rPr>
-              <a:t>Работать только по допуску и в паре, со страховкой</a:t>
+              <a:t>Работать только по допуску, в паре и со страховкой</a:t>
             </a:r>
           </a:p>
           <a:p>
@@ -15286,7 +16354,7 @@
                 </a:solidFill>
                 <a:latin typeface="Calibri"/>
               </a:rPr>
-              <a:t>Не приближаться к башне при обледенении</a:t>
+              <a:t>Не приближаться к башне при обледенении лопастей</a:t>
             </a:r>
           </a:p>
           <a:p>
@@ -15600,7 +16668,7 @@
           <a:p>
             <a:pPr algn="l">
               <a:spcAft>
-                <a:spcPts val="1400"/>
+                <a:spcPts val="1200"/>
               </a:spcAft>
             </a:pPr>
             <a:r>
@@ -15619,13 +16687,13 @@
                 </a:solidFill>
                 <a:latin typeface="Calibri"/>
               </a:rPr>
-              <a:t>Обесточить цепь или отстранить предметом из диэлектрика</a:t>
+              <a:t>Обесточить цепь или отстранить провод сухим диэлектрическим предметом</a:t>
             </a:r>
           </a:p>
           <a:p>
             <a:pPr algn="l">
               <a:spcAft>
-                <a:spcPts val="1400"/>
+                <a:spcPts val="1200"/>
               </a:spcAft>
             </a:pPr>
             <a:r>
@@ -15644,13 +16712,13 @@
                 </a:solidFill>
                 <a:latin typeface="Calibri"/>
               </a:rPr>
-              <a:t>Не прикасаться к пострадавшему под напряжением</a:t>
+              <a:t>Не касаться пострадавшего, пока он под напряжением</a:t>
             </a:r>
           </a:p>
           <a:p>
             <a:pPr algn="l">
               <a:spcAft>
-                <a:spcPts val="1400"/>
+                <a:spcPts val="1200"/>
               </a:spcAft>
             </a:pPr>
             <a:r>
@@ -15669,13 +16737,13 @@
                 </a:solidFill>
                 <a:latin typeface="Calibri"/>
               </a:rPr>
-              <a:t>При отсутствии дыхания начать реанимацию</a:t>
+              <a:t>Нет дыхания — начать сердечно-лёгочную реанимацию</a:t>
             </a:r>
           </a:p>
           <a:p>
             <a:pPr algn="l">
               <a:spcAft>
-                <a:spcPts val="1400"/>
+                <a:spcPts val="1200"/>
               </a:spcAft>
             </a:pPr>
             <a:r>
@@ -15694,7 +16762,7 @@
                 </a:solidFill>
                 <a:latin typeface="Calibri"/>
               </a:rPr>
-              <a:t>При падении не перемещать пострадавшего без нужды</a:t>
+              <a:t>После падения без нужды не перемещать пострадавшего</a:t>
             </a:r>
           </a:p>
         </p:txBody>
@@ -15804,7 +16872,7 @@
           <a:p>
             <a:pPr algn="l">
               <a:spcAft>
-                <a:spcPts val="1400"/>
+                <a:spcPts val="1200"/>
               </a:spcAft>
             </a:pPr>
             <a:r>
@@ -15823,13 +16891,13 @@
                 </a:solidFill>
                 <a:latin typeface="Calibri"/>
               </a:rPr>
-              <a:t>Сообщить диспетчеру и позвонить в 112</a:t>
+              <a:t>Сообщить диспетчеру объекта и позвонить в 112</a:t>
             </a:r>
           </a:p>
           <a:p>
             <a:pPr algn="l">
               <a:spcAft>
-                <a:spcPts val="1400"/>
+                <a:spcPts val="1200"/>
               </a:spcAft>
             </a:pPr>
             <a:r>
@@ -15854,7 +16922,7 @@
           <a:p>
             <a:pPr algn="l">
               <a:spcAft>
-                <a:spcPts val="1400"/>
+                <a:spcPts val="1200"/>
               </a:spcAft>
             </a:pPr>
             <a:r>
@@ -15873,13 +16941,13 @@
                 </a:solidFill>
                 <a:latin typeface="Calibri"/>
               </a:rPr>
-              <a:t>Литиевые батареи: держаться дальше от дыма</a:t>
+              <a:t>Горят литиевые батареи: держаться дальше от дыма</a:t>
             </a:r>
           </a:p>
           <a:p>
             <a:pPr algn="l">
               <a:spcAft>
-                <a:spcPts val="1400"/>
+                <a:spcPts val="1200"/>
               </a:spcAft>
             </a:pPr>
             <a:r>
@@ -16174,7 +17242,7 @@
                 </a:solidFill>
                 <a:latin typeface="Calibri"/>
               </a:rPr>
-              <a:t>Главные риски: электричество, высота и огонь</a:t>
+              <a:t>Главные риски на объектах ВИЭ: электричество, высота и огонь</a:t>
             </a:r>
           </a:p>
         </p:txBody>
@@ -16262,7 +17330,7 @@
                 </a:solidFill>
                 <a:latin typeface="Calibri"/>
               </a:rPr>
-              <a:t>Постоянный ток на панелях опасен, пока есть свет</a:t>
+              <a:t>Постоянный ток на панелях опасен, пока на них падает свет</a:t>
             </a:r>
           </a:p>
         </p:txBody>
@@ -16438,7 +17506,7 @@
                 </a:solidFill>
                 <a:latin typeface="Calibri"/>
               </a:rPr>
-              <a:t>Высота требует допуска, СИЗ и плана спасения</a:t>
+              <a:t>Высота требует допуска, СИЗ, страховки и плана спасения</a:t>
             </a:r>
           </a:p>
         </p:txBody>
@@ -16526,7 +17594,7 @@
                 </a:solidFill>
                 <a:latin typeface="Calibri"/>
               </a:rPr>
-              <a:t>Знайте знаки и порядок действий при аварии</a:t>
+              <a:t>Знайте знаки и порядок действий при аварии и пожаре батарей</a:t>
             </a:r>
           </a:p>
         </p:txBody>
@@ -16535,6 +17603,1341 @@
     <p:extLst>
       <p:ext uri="{BB962C8B-B14F-4D97-AF65-F5344CB8AC3E}">
         <p14:creationId xmlns:p14="http://schemas.microsoft.com/office/powerpoint/2010/main" val="3686358602"/>
+      </p:ext>
+    </p:extLst>
+  </p:cSld>
+  <p:clrMapOvr>
+    <a:masterClrMapping/>
+  </p:clrMapOvr>
+</p:sld>
+</file>
+
+<file path=ppt/slides/slide35.xml><?xml version="1.0" encoding="utf-8"?>
+<p:sld xmlns:a="http://schemas.openxmlformats.org/drawingml/2006/main" xmlns:r="http://schemas.openxmlformats.org/officeDocument/2006/relationships" xmlns:p="http://schemas.openxmlformats.org/presentationml/2006/main">
+  <p:cSld>
+    <p:spTree>
+      <p:nvGrpSpPr>
+        <p:cNvPr id="1" name=""/>
+        <p:cNvGrpSpPr/>
+        <p:nvPr/>
+      </p:nvGrpSpPr>
+      <p:grpSpPr>
+        <a:xfrm>
+          <a:off x="0" y="0"/>
+          <a:ext cx="0" cy="0"/>
+          <a:chOff x="0" y="0"/>
+          <a:chExt cx="0" cy="0"/>
+        </a:xfrm>
+      </p:grpSpPr>
+      <p:sp>
+        <p:nvSpPr>
+          <p:cNvPr id="2" name="Заголовок 1"/>
+          <p:cNvSpPr>
+            <a:spLocks noGrp="1"/>
+          </p:cNvSpPr>
+          <p:nvPr>
+            <p:ph type="title"/>
+          </p:nvPr>
+        </p:nvSpPr>
+        <p:spPr>
+          <a:xfrm>
+            <a:off x="407988" y="765175"/>
+            <a:ext cx="10515600" cy="681885"/>
+          </a:xfrm>
+        </p:spPr>
+        <p:txBody>
+          <a:bodyPr>
+            <a:normAutofit/>
+          </a:bodyPr>
+          <a:lstStyle/>
+          <a:p>
+            <a:r>
+              <a:rPr lang="ru-RU" sz="2800" b="1" dirty="0">
+                <a:solidFill>
+                  <a:schemeClr val="tx1">
+                    <a:lumMod val="85000"/>
+                    <a:lumOff val="15000"/>
+                  </a:schemeClr>
+                </a:solidFill>
+                <a:latin typeface="+mn-lt"/>
+              </a:rPr>
+              <a:t>Обучение, допуск и медконтроль персонала</a:t>
+            </a:r>
+          </a:p>
+        </p:txBody>
+      </p:sp>
+      <p:sp>
+        <p:nvSpPr>
+          <p:cNvPr id="6" name="Прямоугольник 5"/>
+          <p:cNvSpPr/>
+          <p:nvPr/>
+        </p:nvSpPr>
+        <p:spPr>
+          <a:xfrm>
+            <a:off x="8330738" y="132112"/>
+            <a:ext cx="3473334" cy="338554"/>
+          </a:xfrm>
+          <a:prstGeom prst="rect">
+            <a:avLst/>
+          </a:prstGeom>
+        </p:spPr>
+        <p:txBody>
+          <a:bodyPr wrap="square">
+            <a:spAutoFit/>
+          </a:bodyPr>
+          <a:lstStyle/>
+          <a:p>
+            <a:pPr lvl="0" algn="r"/>
+            <a:r>
+              <a:rPr lang="ru-RU" sz="1600" b="1" dirty="0">
+                <a:solidFill>
+                  <a:schemeClr val="bg1"/>
+                </a:solidFill>
+              </a:rPr>
+              <a:t>ВИЭ: БЕЗОПАСНОСТЬ</a:t>
+            </a:r>
+          </a:p>
+        </p:txBody>
+      </p:sp>
+      <p:sp>
+        <p:nvSpPr>
+          <p:cNvPr id="8" name="Прямоугольник 7"/>
+          <p:cNvSpPr/>
+          <p:nvPr/>
+        </p:nvSpPr>
+        <p:spPr>
+          <a:xfrm>
+            <a:off x="0" y="-2992"/>
+            <a:ext cx="12192000" cy="571403"/>
+          </a:xfrm>
+          <a:prstGeom prst="rect">
+            <a:avLst/>
+          </a:prstGeom>
+          <a:solidFill>
+            <a:schemeClr val="tx1">
+              <a:lumMod val="85000"/>
+              <a:lumOff val="15000"/>
+            </a:schemeClr>
+          </a:solidFill>
+          <a:ln>
+            <a:noFill/>
+          </a:ln>
+        </p:spPr>
+        <p:style>
+          <a:lnRef idx="2">
+            <a:schemeClr val="accent1">
+              <a:shade val="50000"/>
+            </a:schemeClr>
+          </a:lnRef>
+          <a:fillRef idx="1">
+            <a:schemeClr val="accent1"/>
+          </a:fillRef>
+          <a:effectRef idx="0">
+            <a:schemeClr val="accent1"/>
+          </a:effectRef>
+          <a:fontRef idx="minor">
+            <a:schemeClr val="lt1"/>
+          </a:fontRef>
+        </p:style>
+        <p:txBody>
+          <a:bodyPr rtlCol="0" anchor="ctr"/>
+          <a:lstStyle/>
+          <a:p>
+            <a:pPr algn="ctr"/>
+            <a:endParaRPr lang="ru-RU"/>
+          </a:p>
+        </p:txBody>
+      </p:sp>
+      <p:pic>
+        <p:nvPicPr>
+          <p:cNvPr id="9" name="Рисунок 8"/>
+          <p:cNvPicPr>
+            <a:picLocks noChangeAspect="1"/>
+          </p:cNvPicPr>
+          <p:nvPr/>
+        </p:nvPicPr>
+        <p:blipFill>
+          <a:blip r:embed="rId2" cstate="print">
+            <a:extLst>
+              <a:ext uri="{28A0092B-C50C-407E-A947-70E740481C1C}">
+                <a14:useLocalDpi xmlns:a14="http://schemas.microsoft.com/office/drawing/2010/main" val="0"/>
+              </a:ext>
+            </a:extLst>
+          </a:blip>
+          <a:stretch>
+            <a:fillRect/>
+          </a:stretch>
+        </p:blipFill>
+        <p:spPr>
+          <a:xfrm>
+            <a:off x="396995" y="141442"/>
+            <a:ext cx="3185962" cy="351041"/>
+          </a:xfrm>
+          <a:prstGeom prst="rect">
+            <a:avLst/>
+          </a:prstGeom>
+        </p:spPr>
+      </p:pic>
+      <p:graphicFrame>
+        <p:nvGraphicFramePr>
+          <p:cNvPr id="10" name="Допуск персонала"/>
+          <p:cNvGraphicFramePr>
+            <a:graphicFrameLocks noGrp="1"/>
+          </p:cNvGraphicFramePr>
+          <p:nvPr/>
+        </p:nvGraphicFramePr>
+        <p:xfrm>
+          <a:off x="594360" y="1691640"/>
+          <a:ext cx="11018520" cy="4343400"/>
+        </p:xfrm>
+        <a:graphic>
+          <a:graphicData uri="http://schemas.openxmlformats.org/drawingml/2006/table">
+            <a:tbl>
+              <a:tblPr firstRow="1" bandRow="1">
+                <a:tableStyleId>{5C22544A-7EE6-4342-B048-85BDC9FD1C3A}</a:tableStyleId>
+              </a:tblPr>
+              <a:tblGrid>
+                <a:gridCol w="2560320"/>
+                <a:gridCol w="5120640"/>
+                <a:gridCol w="3337560"/>
+              </a:tblGrid>
+              <a:tr h="457200">
+                <a:tc>
+                  <a:txBody>
+                    <a:bodyPr/>
+                    <a:lstStyle/>
+                    <a:p>
+                      <a:pPr algn="l"/>
+                      <a:r>
+                        <a:rPr sz="1500" b="1">
+                          <a:solidFill>
+                            <a:srgbClr val="FFED00"/>
+                          </a:solidFill>
+                          <a:latin typeface="Calibri"/>
+                        </a:rPr>
+                        <a:t>Что нужно</a:t>
+                      </a:r>
+                    </a:p>
+                  </a:txBody>
+                  <a:tcPr anchor="ctr">
+                    <a:solidFill>
+                      <a:srgbClr val="2B2B2B"/>
+                    </a:solidFill>
+                  </a:tcPr>
+                </a:tc>
+                <a:tc>
+                  <a:txBody>
+                    <a:bodyPr/>
+                    <a:lstStyle/>
+                    <a:p>
+                      <a:pPr algn="l"/>
+                      <a:r>
+                        <a:rPr sz="1500" b="1">
+                          <a:solidFill>
+                            <a:srgbClr val="FFED00"/>
+                          </a:solidFill>
+                          <a:latin typeface="Calibri"/>
+                        </a:rPr>
+                        <a:t>Требование</a:t>
+                      </a:r>
+                    </a:p>
+                  </a:txBody>
+                  <a:tcPr anchor="ctr">
+                    <a:solidFill>
+                      <a:srgbClr val="2B2B2B"/>
+                    </a:solidFill>
+                  </a:tcPr>
+                </a:tc>
+                <a:tc>
+                  <a:txBody>
+                    <a:bodyPr/>
+                    <a:lstStyle/>
+                    <a:p>
+                      <a:pPr algn="l"/>
+                      <a:r>
+                        <a:rPr sz="1500" b="1">
+                          <a:solidFill>
+                            <a:srgbClr val="FFED00"/>
+                          </a:solidFill>
+                          <a:latin typeface="Calibri"/>
+                        </a:rPr>
+                        <a:t>Зачем</a:t>
+                      </a:r>
+                    </a:p>
+                  </a:txBody>
+                  <a:tcPr anchor="ctr">
+                    <a:solidFill>
+                      <a:srgbClr val="2B2B2B"/>
+                    </a:solidFill>
+                  </a:tcPr>
+                </a:tc>
+              </a:tr>
+              <a:tr h="777240">
+                <a:tc>
+                  <a:txBody>
+                    <a:bodyPr/>
+                    <a:lstStyle/>
+                    <a:p>
+                      <a:pPr algn="l"/>
+                      <a:r>
+                        <a:rPr sz="1400" b="1">
+                          <a:solidFill>
+                            <a:srgbClr val="2B2B2B"/>
+                          </a:solidFill>
+                          <a:latin typeface="Calibri"/>
+                        </a:rPr>
+                        <a:t>Группа по электробезопасности</a:t>
+                      </a:r>
+                    </a:p>
+                  </a:txBody>
+                  <a:tcPr anchor="ctr">
+                    <a:solidFill>
+                      <a:srgbClr val="F1F1F1"/>
+                    </a:solidFill>
+                  </a:tcPr>
+                </a:tc>
+                <a:tc>
+                  <a:txBody>
+                    <a:bodyPr/>
+                    <a:lstStyle/>
+                    <a:p>
+                      <a:pPr algn="l"/>
+                      <a:r>
+                        <a:rPr sz="1400" b="0">
+                          <a:solidFill>
+                            <a:srgbClr val="2B2B2B"/>
+                          </a:solidFill>
+                          <a:latin typeface="Calibri"/>
+                        </a:rPr>
+                        <a:t>Присваивается по результатам проверки знаний, от II до V группы в зависимости от видов работ</a:t>
+                      </a:r>
+                    </a:p>
+                  </a:txBody>
+                  <a:tcPr anchor="ctr">
+                    <a:solidFill>
+                      <a:srgbClr val="F1F1F1"/>
+                    </a:solidFill>
+                  </a:tcPr>
+                </a:tc>
+                <a:tc>
+                  <a:txBody>
+                    <a:bodyPr/>
+                    <a:lstStyle/>
+                    <a:p>
+                      <a:pPr algn="l"/>
+                      <a:r>
+                        <a:rPr sz="1400" b="0">
+                          <a:solidFill>
+                            <a:srgbClr val="2B2B2B"/>
+                          </a:solidFill>
+                          <a:latin typeface="Calibri"/>
+                        </a:rPr>
+                        <a:t>Определяет, какие операции с электроустановкой разрешены</a:t>
+                      </a:r>
+                    </a:p>
+                  </a:txBody>
+                  <a:tcPr anchor="ctr">
+                    <a:solidFill>
+                      <a:srgbClr val="F1F1F1"/>
+                    </a:solidFill>
+                  </a:tcPr>
+                </a:tc>
+              </a:tr>
+              <a:tr h="777240">
+                <a:tc>
+                  <a:txBody>
+                    <a:bodyPr/>
+                    <a:lstStyle/>
+                    <a:p>
+                      <a:pPr algn="l"/>
+                      <a:r>
+                        <a:rPr sz="1400" b="1">
+                          <a:solidFill>
+                            <a:srgbClr val="2B2B2B"/>
+                          </a:solidFill>
+                          <a:latin typeface="Calibri"/>
+                        </a:rPr>
+                        <a:t>Допуск к работам на высоте</a:t>
+                      </a:r>
+                    </a:p>
+                  </a:txBody>
+                  <a:tcPr anchor="ctr">
+                    <a:solidFill>
+                      <a:srgbClr val="FFFFFF"/>
+                    </a:solidFill>
+                  </a:tcPr>
+                </a:tc>
+                <a:tc>
+                  <a:txBody>
+                    <a:bodyPr/>
+                    <a:lstStyle/>
+                    <a:p>
+                      <a:pPr algn="l"/>
+                      <a:r>
+                        <a:rPr sz="1400" b="0">
+                          <a:solidFill>
+                            <a:srgbClr val="2B2B2B"/>
+                          </a:solidFill>
+                          <a:latin typeface="Calibri"/>
+                        </a:rPr>
+                        <a:t>Обучение, медосмотр и группа допуска (1, 2 или 3) по правилам работы на высоте</a:t>
+                      </a:r>
+                    </a:p>
+                  </a:txBody>
+                  <a:tcPr anchor="ctr">
+                    <a:solidFill>
+                      <a:srgbClr val="FFFFFF"/>
+                    </a:solidFill>
+                  </a:tcPr>
+                </a:tc>
+                <a:tc>
+                  <a:txBody>
+                    <a:bodyPr/>
+                    <a:lstStyle/>
+                    <a:p>
+                      <a:pPr algn="l"/>
+                      <a:r>
+                        <a:rPr sz="1400" b="0">
+                          <a:solidFill>
+                            <a:srgbClr val="2B2B2B"/>
+                          </a:solidFill>
+                          <a:latin typeface="Calibri"/>
+                        </a:rPr>
+                        <a:t>Подтверждает умение работать и страховать</a:t>
+                      </a:r>
+                    </a:p>
+                  </a:txBody>
+                  <a:tcPr anchor="ctr">
+                    <a:solidFill>
+                      <a:srgbClr val="FFFFFF"/>
+                    </a:solidFill>
+                  </a:tcPr>
+                </a:tc>
+              </a:tr>
+              <a:tr h="777240">
+                <a:tc>
+                  <a:txBody>
+                    <a:bodyPr/>
+                    <a:lstStyle/>
+                    <a:p>
+                      <a:pPr algn="l"/>
+                      <a:r>
+                        <a:rPr sz="1400" b="1">
+                          <a:solidFill>
+                            <a:srgbClr val="2B2B2B"/>
+                          </a:solidFill>
+                          <a:latin typeface="Calibri"/>
+                        </a:rPr>
+                        <a:t>Инструктажи</a:t>
+                      </a:r>
+                    </a:p>
+                  </a:txBody>
+                  <a:tcPr anchor="ctr">
+                    <a:solidFill>
+                      <a:srgbClr val="F1F1F1"/>
+                    </a:solidFill>
+                  </a:tcPr>
+                </a:tc>
+                <a:tc>
+                  <a:txBody>
+                    <a:bodyPr/>
+                    <a:lstStyle/>
+                    <a:p>
+                      <a:pPr algn="l"/>
+                      <a:r>
+                        <a:rPr sz="1400" b="0">
+                          <a:solidFill>
+                            <a:srgbClr val="2B2B2B"/>
+                          </a:solidFill>
+                          <a:latin typeface="Calibri"/>
+                        </a:rPr>
+                        <a:t>Вводный, первичный на рабочем месте, повторный, внеплановый и целевой перед опасными работами</a:t>
+                      </a:r>
+                    </a:p>
+                  </a:txBody>
+                  <a:tcPr anchor="ctr">
+                    <a:solidFill>
+                      <a:srgbClr val="F1F1F1"/>
+                    </a:solidFill>
+                  </a:tcPr>
+                </a:tc>
+                <a:tc>
+                  <a:txBody>
+                    <a:bodyPr/>
+                    <a:lstStyle/>
+                    <a:p>
+                      <a:pPr algn="l"/>
+                      <a:r>
+                        <a:rPr sz="1400" b="0">
+                          <a:solidFill>
+                            <a:srgbClr val="2B2B2B"/>
+                          </a:solidFill>
+                          <a:latin typeface="Calibri"/>
+                        </a:rPr>
+                        <a:t>Персонал знает риски конкретного объекта</a:t>
+                      </a:r>
+                    </a:p>
+                  </a:txBody>
+                  <a:tcPr anchor="ctr">
+                    <a:solidFill>
+                      <a:srgbClr val="F1F1F1"/>
+                    </a:solidFill>
+                  </a:tcPr>
+                </a:tc>
+              </a:tr>
+              <a:tr h="777240">
+                <a:tc>
+                  <a:txBody>
+                    <a:bodyPr/>
+                    <a:lstStyle/>
+                    <a:p>
+                      <a:pPr algn="l"/>
+                      <a:r>
+                        <a:rPr sz="1400" b="1">
+                          <a:solidFill>
+                            <a:srgbClr val="2B2B2B"/>
+                          </a:solidFill>
+                          <a:latin typeface="Calibri"/>
+                        </a:rPr>
+                        <a:t>Обучение GWO</a:t>
+                      </a:r>
+                    </a:p>
+                  </a:txBody>
+                  <a:tcPr anchor="ctr">
+                    <a:solidFill>
+                      <a:srgbClr val="FFFFFF"/>
+                    </a:solidFill>
+                  </a:tcPr>
+                </a:tc>
+                <a:tc>
+                  <a:txBody>
+                    <a:bodyPr/>
+                    <a:lstStyle/>
+                    <a:p>
+                      <a:pPr algn="l"/>
+                      <a:r>
+                        <a:rPr sz="1400" b="0">
+                          <a:solidFill>
+                            <a:srgbClr val="2B2B2B"/>
+                          </a:solidFill>
+                          <a:latin typeface="Calibri"/>
+                        </a:rPr>
+                        <a:t>Курсы по работе на высоте, спасению с башни, первой помощи и пожарной безопасности в ветроэнергетике</a:t>
+                      </a:r>
+                    </a:p>
+                  </a:txBody>
+                  <a:tcPr anchor="ctr">
+                    <a:solidFill>
+                      <a:srgbClr val="FFFFFF"/>
+                    </a:solidFill>
+                  </a:tcPr>
+                </a:tc>
+                <a:tc>
+                  <a:txBody>
+                    <a:bodyPr/>
+                    <a:lstStyle/>
+                    <a:p>
+                      <a:pPr algn="l"/>
+                      <a:r>
+                        <a:rPr sz="1400" b="0">
+                          <a:solidFill>
+                            <a:srgbClr val="2B2B2B"/>
+                          </a:solidFill>
+                          <a:latin typeface="Calibri"/>
+                        </a:rPr>
+                        <a:t>Единые навыки и спасение с башни</a:t>
+                      </a:r>
+                    </a:p>
+                  </a:txBody>
+                  <a:tcPr anchor="ctr">
+                    <a:solidFill>
+                      <a:srgbClr val="FFFFFF"/>
+                    </a:solidFill>
+                  </a:tcPr>
+                </a:tc>
+              </a:tr>
+              <a:tr h="777240">
+                <a:tc>
+                  <a:txBody>
+                    <a:bodyPr/>
+                    <a:lstStyle/>
+                    <a:p>
+                      <a:pPr algn="l"/>
+                      <a:r>
+                        <a:rPr sz="1400" b="1">
+                          <a:solidFill>
+                            <a:srgbClr val="2B2B2B"/>
+                          </a:solidFill>
+                          <a:latin typeface="Calibri"/>
+                        </a:rPr>
+                        <a:t>Медосмотры</a:t>
+                      </a:r>
+                    </a:p>
+                  </a:txBody>
+                  <a:tcPr anchor="ctr">
+                    <a:solidFill>
+                      <a:srgbClr val="F1F1F1"/>
+                    </a:solidFill>
+                  </a:tcPr>
+                </a:tc>
+                <a:tc>
+                  <a:txBody>
+                    <a:bodyPr/>
+                    <a:lstStyle/>
+                    <a:p>
+                      <a:pPr algn="l"/>
+                      <a:r>
+                        <a:rPr sz="1400" b="0">
+                          <a:solidFill>
+                            <a:srgbClr val="2B2B2B"/>
+                          </a:solidFill>
+                          <a:latin typeface="Calibri"/>
+                        </a:rPr>
+                        <a:t>Предварительные и периодические осмотры для работ на высоте и во вредных условиях</a:t>
+                      </a:r>
+                    </a:p>
+                  </a:txBody>
+                  <a:tcPr anchor="ctr">
+                    <a:solidFill>
+                      <a:srgbClr val="F1F1F1"/>
+                    </a:solidFill>
+                  </a:tcPr>
+                </a:tc>
+                <a:tc>
+                  <a:txBody>
+                    <a:bodyPr/>
+                    <a:lstStyle/>
+                    <a:p>
+                      <a:pPr algn="l"/>
+                      <a:r>
+                        <a:rPr sz="1400" b="0">
+                          <a:solidFill>
+                            <a:srgbClr val="2B2B2B"/>
+                          </a:solidFill>
+                          <a:latin typeface="Calibri"/>
+                        </a:rPr>
+                        <a:t>Исключает работу при противопоказаниях</a:t>
+                      </a:r>
+                    </a:p>
+                  </a:txBody>
+                  <a:tcPr anchor="ctr">
+                    <a:solidFill>
+                      <a:srgbClr val="F1F1F1"/>
+                    </a:solidFill>
+                  </a:tcPr>
+                </a:tc>
+              </a:tr>
+            </a:tbl>
+          </a:graphicData>
+        </a:graphic>
+      </p:graphicFrame>
+    </p:spTree>
+    <p:extLst>
+      <p:ext uri="{BB962C8B-B14F-4D97-AF65-F5344CB8AC3E}">
+        <p14:creationId xmlns:p14="http://schemas.microsoft.com/office/powerpoint/2010/main" val="527513127"/>
+      </p:ext>
+    </p:extLst>
+  </p:cSld>
+  <p:clrMapOvr>
+    <a:masterClrMapping/>
+  </p:clrMapOvr>
+</p:sld>
+</file>
+
+<file path=ppt/slides/slide36.xml><?xml version="1.0" encoding="utf-8"?>
+<p:sld xmlns:a="http://schemas.openxmlformats.org/drawingml/2006/main" xmlns:r="http://schemas.openxmlformats.org/officeDocument/2006/relationships" xmlns:p="http://schemas.openxmlformats.org/presentationml/2006/main">
+  <p:cSld>
+    <p:spTree>
+      <p:nvGrpSpPr>
+        <p:cNvPr id="1" name=""/>
+        <p:cNvGrpSpPr/>
+        <p:nvPr/>
+      </p:nvGrpSpPr>
+      <p:grpSpPr>
+        <a:xfrm>
+          <a:off x="0" y="0"/>
+          <a:ext cx="0" cy="0"/>
+          <a:chOff x="0" y="0"/>
+          <a:chExt cx="0" cy="0"/>
+        </a:xfrm>
+      </p:grpSpPr>
+      <p:sp>
+        <p:nvSpPr>
+          <p:cNvPr id="2" name="Заголовок 1"/>
+          <p:cNvSpPr>
+            <a:spLocks noGrp="1"/>
+          </p:cNvSpPr>
+          <p:nvPr>
+            <p:ph type="title"/>
+          </p:nvPr>
+        </p:nvSpPr>
+        <p:spPr>
+          <a:xfrm>
+            <a:off x="407988" y="765175"/>
+            <a:ext cx="10515600" cy="681885"/>
+          </a:xfrm>
+        </p:spPr>
+        <p:txBody>
+          <a:bodyPr>
+            <a:normAutofit/>
+          </a:bodyPr>
+          <a:lstStyle/>
+          <a:p>
+            <a:r>
+              <a:rPr lang="ru-RU" sz="2800" b="1" dirty="0">
+                <a:solidFill>
+                  <a:schemeClr val="tx1">
+                    <a:lumMod val="85000"/>
+                    <a:lumOff val="15000"/>
+                  </a:schemeClr>
+                </a:solidFill>
+                <a:latin typeface="+mn-lt"/>
+              </a:rPr>
+              <a:t>Типичные ошибки и как их избежать</a:t>
+            </a:r>
+          </a:p>
+        </p:txBody>
+      </p:sp>
+      <p:sp>
+        <p:nvSpPr>
+          <p:cNvPr id="6" name="Прямоугольник 5"/>
+          <p:cNvSpPr/>
+          <p:nvPr/>
+        </p:nvSpPr>
+        <p:spPr>
+          <a:xfrm>
+            <a:off x="8330738" y="132112"/>
+            <a:ext cx="3473334" cy="338554"/>
+          </a:xfrm>
+          <a:prstGeom prst="rect">
+            <a:avLst/>
+          </a:prstGeom>
+        </p:spPr>
+        <p:txBody>
+          <a:bodyPr wrap="square">
+            <a:spAutoFit/>
+          </a:bodyPr>
+          <a:lstStyle/>
+          <a:p>
+            <a:pPr lvl="0" algn="r"/>
+            <a:r>
+              <a:rPr lang="ru-RU" sz="1600" b="1" dirty="0">
+                <a:solidFill>
+                  <a:schemeClr val="bg1"/>
+                </a:solidFill>
+              </a:rPr>
+              <a:t>ВИЭ: БЕЗОПАСНОСТЬ</a:t>
+            </a:r>
+          </a:p>
+        </p:txBody>
+      </p:sp>
+      <p:sp>
+        <p:nvSpPr>
+          <p:cNvPr id="8" name="Прямоугольник 7"/>
+          <p:cNvSpPr/>
+          <p:nvPr/>
+        </p:nvSpPr>
+        <p:spPr>
+          <a:xfrm>
+            <a:off x="0" y="-2992"/>
+            <a:ext cx="12192000" cy="571403"/>
+          </a:xfrm>
+          <a:prstGeom prst="rect">
+            <a:avLst/>
+          </a:prstGeom>
+          <a:solidFill>
+            <a:schemeClr val="tx1">
+              <a:lumMod val="85000"/>
+              <a:lumOff val="15000"/>
+            </a:schemeClr>
+          </a:solidFill>
+          <a:ln>
+            <a:noFill/>
+          </a:ln>
+        </p:spPr>
+        <p:style>
+          <a:lnRef idx="2">
+            <a:schemeClr val="accent1">
+              <a:shade val="50000"/>
+            </a:schemeClr>
+          </a:lnRef>
+          <a:fillRef idx="1">
+            <a:schemeClr val="accent1"/>
+          </a:fillRef>
+          <a:effectRef idx="0">
+            <a:schemeClr val="accent1"/>
+          </a:effectRef>
+          <a:fontRef idx="minor">
+            <a:schemeClr val="lt1"/>
+          </a:fontRef>
+        </p:style>
+        <p:txBody>
+          <a:bodyPr rtlCol="0" anchor="ctr"/>
+          <a:lstStyle/>
+          <a:p>
+            <a:pPr algn="ctr"/>
+            <a:endParaRPr lang="ru-RU"/>
+          </a:p>
+        </p:txBody>
+      </p:sp>
+      <p:pic>
+        <p:nvPicPr>
+          <p:cNvPr id="9" name="Рисунок 8"/>
+          <p:cNvPicPr>
+            <a:picLocks noChangeAspect="1"/>
+          </p:cNvPicPr>
+          <p:nvPr/>
+        </p:nvPicPr>
+        <p:blipFill>
+          <a:blip r:embed="rId2" cstate="print">
+            <a:extLst>
+              <a:ext uri="{28A0092B-C50C-407E-A947-70E740481C1C}">
+                <a14:useLocalDpi xmlns:a14="http://schemas.microsoft.com/office/drawing/2010/main" val="0"/>
+              </a:ext>
+            </a:extLst>
+          </a:blip>
+          <a:stretch>
+            <a:fillRect/>
+          </a:stretch>
+        </p:blipFill>
+        <p:spPr>
+          <a:xfrm>
+            <a:off x="396995" y="141442"/>
+            <a:ext cx="3185962" cy="351041"/>
+          </a:xfrm>
+          <a:prstGeom prst="rect">
+            <a:avLst/>
+          </a:prstGeom>
+        </p:spPr>
+      </p:pic>
+      <p:graphicFrame>
+        <p:nvGraphicFramePr>
+          <p:cNvPr id="10" name="Типичные ошибки"/>
+          <p:cNvGraphicFramePr>
+            <a:graphicFrameLocks noGrp="1"/>
+          </p:cNvGraphicFramePr>
+          <p:nvPr/>
+        </p:nvGraphicFramePr>
+        <p:xfrm>
+          <a:off x="594360" y="1691640"/>
+          <a:ext cx="11018520" cy="4297680"/>
+        </p:xfrm>
+        <a:graphic>
+          <a:graphicData uri="http://schemas.openxmlformats.org/drawingml/2006/table">
+            <a:tbl>
+              <a:tblPr firstRow="1" bandRow="1">
+                <a:tableStyleId>{5C22544A-7EE6-4342-B048-85BDC9FD1C3A}</a:tableStyleId>
+              </a:tblPr>
+              <a:tblGrid>
+                <a:gridCol w="3657600"/>
+                <a:gridCol w="3291840"/>
+                <a:gridCol w="4069080"/>
+              </a:tblGrid>
+              <a:tr h="457200">
+                <a:tc>
+                  <a:txBody>
+                    <a:bodyPr/>
+                    <a:lstStyle/>
+                    <a:p>
+                      <a:pPr algn="l"/>
+                      <a:r>
+                        <a:rPr sz="1500" b="1">
+                          <a:solidFill>
+                            <a:srgbClr val="FFED00"/>
+                          </a:solidFill>
+                          <a:latin typeface="Calibri"/>
+                        </a:rPr>
+                        <a:t>Ошибка</a:t>
+                      </a:r>
+                    </a:p>
+                  </a:txBody>
+                  <a:tcPr anchor="ctr">
+                    <a:solidFill>
+                      <a:srgbClr val="2B2B2B"/>
+                    </a:solidFill>
+                  </a:tcPr>
+                </a:tc>
+                <a:tc>
+                  <a:txBody>
+                    <a:bodyPr/>
+                    <a:lstStyle/>
+                    <a:p>
+                      <a:pPr algn="l"/>
+                      <a:r>
+                        <a:rPr sz="1500" b="1">
+                          <a:solidFill>
+                            <a:srgbClr val="FFED00"/>
+                          </a:solidFill>
+                          <a:latin typeface="Calibri"/>
+                        </a:rPr>
+                        <a:t>К чему приводит</a:t>
+                      </a:r>
+                    </a:p>
+                  </a:txBody>
+                  <a:tcPr anchor="ctr">
+                    <a:solidFill>
+                      <a:srgbClr val="2B2B2B"/>
+                    </a:solidFill>
+                  </a:tcPr>
+                </a:tc>
+                <a:tc>
+                  <a:txBody>
+                    <a:bodyPr/>
+                    <a:lstStyle/>
+                    <a:p>
+                      <a:pPr algn="l"/>
+                      <a:r>
+                        <a:rPr sz="1500" b="1">
+                          <a:solidFill>
+                            <a:srgbClr val="FFED00"/>
+                          </a:solidFill>
+                          <a:latin typeface="Calibri"/>
+                        </a:rPr>
+                        <a:t>Как избежать</a:t>
+                      </a:r>
+                    </a:p>
+                  </a:txBody>
+                  <a:tcPr anchor="ctr">
+                    <a:solidFill>
+                      <a:srgbClr val="2B2B2B"/>
+                    </a:solidFill>
+                  </a:tcPr>
+                </a:tc>
+              </a:tr>
+              <a:tr h="640080">
+                <a:tc>
+                  <a:txBody>
+                    <a:bodyPr/>
+                    <a:lstStyle/>
+                    <a:p>
+                      <a:pPr algn="l"/>
+                      <a:r>
+                        <a:rPr sz="1400" b="1">
+                          <a:solidFill>
+                            <a:srgbClr val="2B2B2B"/>
+                          </a:solidFill>
+                          <a:latin typeface="Calibri"/>
+                        </a:rPr>
+                        <a:t>Работа без отключения и проверки напряжения</a:t>
+                      </a:r>
+                    </a:p>
+                  </a:txBody>
+                  <a:tcPr anchor="ctr">
+                    <a:solidFill>
+                      <a:srgbClr val="F1F1F1"/>
+                    </a:solidFill>
+                  </a:tcPr>
+                </a:tc>
+                <a:tc>
+                  <a:txBody>
+                    <a:bodyPr/>
+                    <a:lstStyle/>
+                    <a:p>
+                      <a:pPr algn="l"/>
+                      <a:r>
+                        <a:rPr sz="1400" b="0">
+                          <a:solidFill>
+                            <a:srgbClr val="2B2B2B"/>
+                          </a:solidFill>
+                          <a:latin typeface="Calibri"/>
+                        </a:rPr>
+                        <a:t>Поражение током, дуга, ожоги</a:t>
+                      </a:r>
+                    </a:p>
+                  </a:txBody>
+                  <a:tcPr anchor="ctr">
+                    <a:solidFill>
+                      <a:srgbClr val="F1F1F1"/>
+                    </a:solidFill>
+                  </a:tcPr>
+                </a:tc>
+                <a:tc>
+                  <a:txBody>
+                    <a:bodyPr/>
+                    <a:lstStyle/>
+                    <a:p>
+                      <a:pPr algn="l"/>
+                      <a:r>
+                        <a:rPr sz="1400" b="0">
+                          <a:solidFill>
+                            <a:srgbClr val="2B2B2B"/>
+                          </a:solidFill>
+                          <a:latin typeface="Calibri"/>
+                        </a:rPr>
+                        <a:t>Отключить, заблокировать, проверить прибором</a:t>
+                      </a:r>
+                    </a:p>
+                  </a:txBody>
+                  <a:tcPr anchor="ctr">
+                    <a:solidFill>
+                      <a:srgbClr val="F1F1F1"/>
+                    </a:solidFill>
+                  </a:tcPr>
+                </a:tc>
+              </a:tr>
+              <a:tr h="640080">
+                <a:tc>
+                  <a:txBody>
+                    <a:bodyPr/>
+                    <a:lstStyle/>
+                    <a:p>
+                      <a:pPr algn="l"/>
+                      <a:r>
+                        <a:rPr sz="1400" b="1">
+                          <a:solidFill>
+                            <a:srgbClr val="2B2B2B"/>
+                          </a:solidFill>
+                          <a:latin typeface="Calibri"/>
+                        </a:rPr>
+                        <a:t>Снятие чужой блокировки «на минуту»</a:t>
+                      </a:r>
+                    </a:p>
+                  </a:txBody>
+                  <a:tcPr anchor="ctr">
+                    <a:solidFill>
+                      <a:srgbClr val="FFFFFF"/>
+                    </a:solidFill>
+                  </a:tcPr>
+                </a:tc>
+                <a:tc>
+                  <a:txBody>
+                    <a:bodyPr/>
+                    <a:lstStyle/>
+                    <a:p>
+                      <a:pPr algn="l"/>
+                      <a:r>
+                        <a:rPr sz="1400" b="0">
+                          <a:solidFill>
+                            <a:srgbClr val="2B2B2B"/>
+                          </a:solidFill>
+                          <a:latin typeface="Calibri"/>
+                        </a:rPr>
+                        <a:t>Подача напряжения на людей</a:t>
+                      </a:r>
+                    </a:p>
+                  </a:txBody>
+                  <a:tcPr anchor="ctr">
+                    <a:solidFill>
+                      <a:srgbClr val="FFFFFF"/>
+                    </a:solidFill>
+                  </a:tcPr>
+                </a:tc>
+                <a:tc>
+                  <a:txBody>
+                    <a:bodyPr/>
+                    <a:lstStyle/>
+                    <a:p>
+                      <a:pPr algn="l"/>
+                      <a:r>
+                        <a:rPr sz="1400" b="0">
+                          <a:solidFill>
+                            <a:srgbClr val="2B2B2B"/>
+                          </a:solidFill>
+                          <a:latin typeface="Calibri"/>
+                        </a:rPr>
+                        <a:t>Блокировку снимает тот, кто её установил</a:t>
+                      </a:r>
+                    </a:p>
+                  </a:txBody>
+                  <a:tcPr anchor="ctr">
+                    <a:solidFill>
+                      <a:srgbClr val="FFFFFF"/>
+                    </a:solidFill>
+                  </a:tcPr>
+                </a:tc>
+              </a:tr>
+              <a:tr h="640080">
+                <a:tc>
+                  <a:txBody>
+                    <a:bodyPr/>
+                    <a:lstStyle/>
+                    <a:p>
+                      <a:pPr algn="l"/>
+                      <a:r>
+                        <a:rPr sz="1400" b="1">
+                          <a:solidFill>
+                            <a:srgbClr val="2B2B2B"/>
+                          </a:solidFill>
+                          <a:latin typeface="Calibri"/>
+                        </a:rPr>
+                        <a:t>Работа в одиночку</a:t>
+                      </a:r>
+                    </a:p>
+                  </a:txBody>
+                  <a:tcPr anchor="ctr">
+                    <a:solidFill>
+                      <a:srgbClr val="F1F1F1"/>
+                    </a:solidFill>
+                  </a:tcPr>
+                </a:tc>
+                <a:tc>
+                  <a:txBody>
+                    <a:bodyPr/>
+                    <a:lstStyle/>
+                    <a:p>
+                      <a:pPr algn="l"/>
+                      <a:r>
+                        <a:rPr sz="1400" b="0">
+                          <a:solidFill>
+                            <a:srgbClr val="2B2B2B"/>
+                          </a:solidFill>
+                          <a:latin typeface="Calibri"/>
+                        </a:rPr>
+                        <a:t>Некому помочь при падении или ударе током</a:t>
+                      </a:r>
+                    </a:p>
+                  </a:txBody>
+                  <a:tcPr anchor="ctr">
+                    <a:solidFill>
+                      <a:srgbClr val="F1F1F1"/>
+                    </a:solidFill>
+                  </a:tcPr>
+                </a:tc>
+                <a:tc>
+                  <a:txBody>
+                    <a:bodyPr/>
+                    <a:lstStyle/>
+                    <a:p>
+                      <a:pPr algn="l"/>
+                      <a:r>
+                        <a:rPr sz="1400" b="0">
+                          <a:solidFill>
+                            <a:srgbClr val="2B2B2B"/>
+                          </a:solidFill>
+                          <a:latin typeface="Calibri"/>
+                        </a:rPr>
+                        <a:t>Работать вдвоём, держать связь</a:t>
+                      </a:r>
+                    </a:p>
+                  </a:txBody>
+                  <a:tcPr anchor="ctr">
+                    <a:solidFill>
+                      <a:srgbClr val="F1F1F1"/>
+                    </a:solidFill>
+                  </a:tcPr>
+                </a:tc>
+              </a:tr>
+              <a:tr h="640080">
+                <a:tc>
+                  <a:txBody>
+                    <a:bodyPr/>
+                    <a:lstStyle/>
+                    <a:p>
+                      <a:pPr algn="l"/>
+                      <a:r>
+                        <a:rPr sz="1400" b="1">
+                          <a:solidFill>
+                            <a:srgbClr val="2B2B2B"/>
+                          </a:solidFill>
+                          <a:latin typeface="Calibri"/>
+                        </a:rPr>
+                        <a:t>Отказ от страховки «ненадолго»</a:t>
+                      </a:r>
+                    </a:p>
+                  </a:txBody>
+                  <a:tcPr anchor="ctr">
+                    <a:solidFill>
+                      <a:srgbClr val="FFFFFF"/>
+                    </a:solidFill>
+                  </a:tcPr>
+                </a:tc>
+                <a:tc>
+                  <a:txBody>
+                    <a:bodyPr/>
+                    <a:lstStyle/>
+                    <a:p>
+                      <a:pPr algn="l"/>
+                      <a:r>
+                        <a:rPr sz="1400" b="0">
+                          <a:solidFill>
+                            <a:srgbClr val="2B2B2B"/>
+                          </a:solidFill>
+                          <a:latin typeface="Calibri"/>
+                        </a:rPr>
+                        <a:t>Падение с крыши или башни</a:t>
+                      </a:r>
+                    </a:p>
+                  </a:txBody>
+                  <a:tcPr anchor="ctr">
+                    <a:solidFill>
+                      <a:srgbClr val="FFFFFF"/>
+                    </a:solidFill>
+                  </a:tcPr>
+                </a:tc>
+                <a:tc>
+                  <a:txBody>
+                    <a:bodyPr/>
+                    <a:lstStyle/>
+                    <a:p>
+                      <a:pPr algn="l"/>
+                      <a:r>
+                        <a:rPr sz="1400" b="0">
+                          <a:solidFill>
+                            <a:srgbClr val="2B2B2B"/>
+                          </a:solidFill>
+                          <a:latin typeface="Calibri"/>
+                        </a:rPr>
+                        <a:t>Пристёгиваться на всём пути, проверять СИЗ</a:t>
+                      </a:r>
+                    </a:p>
+                  </a:txBody>
+                  <a:tcPr anchor="ctr">
+                    <a:solidFill>
+                      <a:srgbClr val="FFFFFF"/>
+                    </a:solidFill>
+                  </a:tcPr>
+                </a:tc>
+              </a:tr>
+              <a:tr h="640080">
+                <a:tc>
+                  <a:txBody>
+                    <a:bodyPr/>
+                    <a:lstStyle/>
+                    <a:p>
+                      <a:pPr algn="l"/>
+                      <a:r>
+                        <a:rPr sz="1400" b="1">
+                          <a:solidFill>
+                            <a:srgbClr val="2B2B2B"/>
+                          </a:solidFill>
+                          <a:latin typeface="Calibri"/>
+                        </a:rPr>
+                        <a:t>Спешка и усталость</a:t>
+                      </a:r>
+                    </a:p>
+                  </a:txBody>
+                  <a:tcPr anchor="ctr">
+                    <a:solidFill>
+                      <a:srgbClr val="F1F1F1"/>
+                    </a:solidFill>
+                  </a:tcPr>
+                </a:tc>
+                <a:tc>
+                  <a:txBody>
+                    <a:bodyPr/>
+                    <a:lstStyle/>
+                    <a:p>
+                      <a:pPr algn="l"/>
+                      <a:r>
+                        <a:rPr sz="1400" b="0">
+                          <a:solidFill>
+                            <a:srgbClr val="2B2B2B"/>
+                          </a:solidFill>
+                          <a:latin typeface="Calibri"/>
+                        </a:rPr>
+                        <a:t>Пропущенные шаги и ошибки</a:t>
+                      </a:r>
+                    </a:p>
+                  </a:txBody>
+                  <a:tcPr anchor="ctr">
+                    <a:solidFill>
+                      <a:srgbClr val="F1F1F1"/>
+                    </a:solidFill>
+                  </a:tcPr>
+                </a:tc>
+                <a:tc>
+                  <a:txBody>
+                    <a:bodyPr/>
+                    <a:lstStyle/>
+                    <a:p>
+                      <a:pPr algn="l"/>
+                      <a:r>
+                        <a:rPr sz="1400" b="0">
+                          <a:solidFill>
+                            <a:srgbClr val="2B2B2B"/>
+                          </a:solidFill>
+                          <a:latin typeface="Calibri"/>
+                        </a:rPr>
+                        <a:t>Планировать время, делать перерывы, работать по списку</a:t>
+                      </a:r>
+                    </a:p>
+                  </a:txBody>
+                  <a:tcPr anchor="ctr">
+                    <a:solidFill>
+                      <a:srgbClr val="F1F1F1"/>
+                    </a:solidFill>
+                  </a:tcPr>
+                </a:tc>
+              </a:tr>
+              <a:tr h="640080">
+                <a:tc>
+                  <a:txBody>
+                    <a:bodyPr/>
+                    <a:lstStyle/>
+                    <a:p>
+                      <a:pPr algn="l"/>
+                      <a:r>
+                        <a:rPr sz="1400" b="1">
+                          <a:solidFill>
+                            <a:srgbClr val="2B2B2B"/>
+                          </a:solidFill>
+                          <a:latin typeface="Calibri"/>
+                        </a:rPr>
+                        <a:t>Игнорирование погоды</a:t>
+                      </a:r>
+                    </a:p>
+                  </a:txBody>
+                  <a:tcPr anchor="ctr">
+                    <a:solidFill>
+                      <a:srgbClr val="FFFFFF"/>
+                    </a:solidFill>
+                  </a:tcPr>
+                </a:tc>
+                <a:tc>
+                  <a:txBody>
+                    <a:bodyPr/>
+                    <a:lstStyle/>
+                    <a:p>
+                      <a:pPr algn="l"/>
+                      <a:r>
+                        <a:rPr sz="1400" b="0">
+                          <a:solidFill>
+                            <a:srgbClr val="2B2B2B"/>
+                          </a:solidFill>
+                          <a:latin typeface="Calibri"/>
+                        </a:rPr>
+                        <a:t>Падение, удар молнии, лёд с лопастей</a:t>
+                      </a:r>
+                    </a:p>
+                  </a:txBody>
+                  <a:tcPr anchor="ctr">
+                    <a:solidFill>
+                      <a:srgbClr val="FFFFFF"/>
+                    </a:solidFill>
+                  </a:tcPr>
+                </a:tc>
+                <a:tc>
+                  <a:txBody>
+                    <a:bodyPr/>
+                    <a:lstStyle/>
+                    <a:p>
+                      <a:pPr algn="l"/>
+                      <a:r>
+                        <a:rPr sz="1400" b="0">
+                          <a:solidFill>
+                            <a:srgbClr val="2B2B2B"/>
+                          </a:solidFill>
+                          <a:latin typeface="Calibri"/>
+                        </a:rPr>
+                        <a:t>Смотреть прогноз, мерить ветер, соблюдать запреты</a:t>
+                      </a:r>
+                    </a:p>
+                  </a:txBody>
+                  <a:tcPr anchor="ctr">
+                    <a:solidFill>
+                      <a:srgbClr val="FFFFFF"/>
+                    </a:solidFill>
+                  </a:tcPr>
+                </a:tc>
+              </a:tr>
+            </a:tbl>
+          </a:graphicData>
+        </a:graphic>
+      </p:graphicFrame>
+    </p:spTree>
+    <p:extLst>
+      <p:ext uri="{BB962C8B-B14F-4D97-AF65-F5344CB8AC3E}">
+        <p14:creationId xmlns:p14="http://schemas.microsoft.com/office/powerpoint/2010/main" val="527513127"/>
       </p:ext>
     </p:extLst>
   </p:cSld>

</xml_diff>